<commit_message>
fix training schedule scraper for sumologic.com markup change
Site swapped .blog-item card divs for direct <a class="training-card__item">
anchors, so the scraper's selectors matched nothing and produced zero
sessions. Update wait/click/parse selectors accordingly and regenerate the
schedule HTML/PPTX outputs.
</commit_message>
<xml_diff>
--- a/CustomTraining/online trainings/training_schedule.pptx
+++ b/CustomTraining/online trainings/training_schedule.pptx
@@ -3207,7 +3207,7 @@
                   <a:srgbClr val="00B4D8"/>
                 </a:solidFill>
               </a:rPr>
-              <a:t>Sumo Logic — Virtual Training Schedule   ·   30 Jun 2026 – 07 Jul 2026   (1/6)</a:t>
+              <a:t>Sumo Logic — Virtual Training Schedule   ·   04 Aug – 11 Aug 2026   (1/6)</a:t>
             </a:r>
           </a:p>
         </p:txBody>
@@ -3581,7 +3581,7 @@
                             <a:srgbClr val="E2E8F0"/>
                           </a:solidFill>
                         </a:rPr>
-                        <a:t>Tue 30 Jun 2026  05:00 AM  →  06:00 AM</a:t>
+                        <a:t>Tue 04 Aug 2026  05:00 AM  →  06:00 AM</a:t>
                       </a:r>
                     </a:p>
                   </a:txBody>
@@ -3623,7 +3623,7 @@
                             <a:srgbClr val="E2E8F0"/>
                           </a:solidFill>
                         </a:rPr>
-                        <a:t>Wed 01 Jul 2026  12:00 AM</a:t>
+                        <a:t>Wed 05 Aug 2026  12:00 AM</a:t>
                       </a:r>
                     </a:p>
                   </a:txBody>
@@ -3665,7 +3665,7 @@
                             <a:srgbClr val="E2E8F0"/>
                           </a:solidFill>
                         </a:rPr>
-                        <a:t>Tue 30 Jun 2026  10:00 PM</a:t>
+                        <a:t>Tue 04 Aug 2026  10:00 PM</a:t>
                       </a:r>
                     </a:p>
                   </a:txBody>
@@ -3707,7 +3707,7 @@
                             <a:srgbClr val="E2E8F0"/>
                           </a:solidFill>
                         </a:rPr>
-                        <a:t>Tue 30 Jun 2026  08:00 PM</a:t>
+                        <a:t>Tue 04 Aug 2026  08:00 PM</a:t>
                       </a:r>
                     </a:p>
                   </a:txBody>
@@ -3749,7 +3749,7 @@
                             <a:srgbClr val="E2E8F0"/>
                           </a:solidFill>
                         </a:rPr>
-                        <a:t>https://events.sumologic.com/welcomewebinaram06302026-event-training</a:t>
+                        <a:t>https://events.sumologic.com/welcomewebinaram08042026-event-training</a:t>
                       </a:r>
                     </a:p>
                   </a:txBody>
@@ -3835,7 +3835,7 @@
                             <a:srgbClr val="E2E8F0"/>
                           </a:solidFill>
                         </a:rPr>
-                        <a:t>Tue 30 Jun 2026  07:00 AM  →  04:00 PM</a:t>
+                        <a:t>Tue 04 Aug 2026  07:00 AM  →  10:00 AM</a:t>
                       </a:r>
                     </a:p>
                   </a:txBody>
@@ -3877,7 +3877,7 @@
                             <a:srgbClr val="E2E8F0"/>
                           </a:solidFill>
                         </a:rPr>
-                        <a:t>Wed 01 Jul 2026  02:00 AM</a:t>
+                        <a:t>Wed 05 Aug 2026  02:00 AM</a:t>
                       </a:r>
                     </a:p>
                   </a:txBody>
@@ -3919,7 +3919,7 @@
                             <a:srgbClr val="E2E8F0"/>
                           </a:solidFill>
                         </a:rPr>
-                        <a:t>Wed 01 Jul 2026  12:00 AM</a:t>
+                        <a:t>Wed 05 Aug 2026  12:00 AM</a:t>
                       </a:r>
                     </a:p>
                   </a:txBody>
@@ -3961,7 +3961,7 @@
                             <a:srgbClr val="E2E8F0"/>
                           </a:solidFill>
                         </a:rPr>
-                        <a:t>Tue 30 Jun 2026  10:00 PM</a:t>
+                        <a:t>Tue 04 Aug 2026  10:00 PM</a:t>
                       </a:r>
                     </a:p>
                   </a:txBody>
@@ -4003,7 +4003,7 @@
                             <a:srgbClr val="E2E8F0"/>
                           </a:solidFill>
                         </a:rPr>
-                        <a:t>https://events.sumologic.com/fundamentalsam06302026-event-training</a:t>
+                        <a:t>https://events.sumologic.com/fundamentalsam08042026-event-training</a:t>
                       </a:r>
                     </a:p>
                   </a:txBody>
@@ -4047,7 +4047,7 @@
                             <a:srgbClr val="E2E8F0"/>
                           </a:solidFill>
                         </a:rPr>
-                        <a:t>Welcome Webinar PM</a:t>
+                        <a:t>Welcome Webinars PM</a:t>
                       </a:r>
                     </a:p>
                   </a:txBody>
@@ -4089,7 +4089,7 @@
                             <a:srgbClr val="E2E8F0"/>
                           </a:solidFill>
                         </a:rPr>
-                        <a:t>Tue 30 Jun 2026  10:00 AM  →  03:00 PM</a:t>
+                        <a:t>Tue 04 Aug 2026  02:00 PM  →  03:00 PM</a:t>
                       </a:r>
                     </a:p>
                   </a:txBody>
@@ -4131,7 +4131,7 @@
                             <a:srgbClr val="E2E8F0"/>
                           </a:solidFill>
                         </a:rPr>
-                        <a:t>Wed 01 Jul 2026  05:00 AM</a:t>
+                        <a:t>Wed 05 Aug 2026  09:00 AM</a:t>
                       </a:r>
                     </a:p>
                   </a:txBody>
@@ -4173,7 +4173,7 @@
                             <a:srgbClr val="E2E8F0"/>
                           </a:solidFill>
                         </a:rPr>
-                        <a:t>Wed 01 Jul 2026  03:00 AM</a:t>
+                        <a:t>Wed 05 Aug 2026  07:00 AM</a:t>
                       </a:r>
                     </a:p>
                   </a:txBody>
@@ -4215,7 +4215,7 @@
                             <a:srgbClr val="E2E8F0"/>
                           </a:solidFill>
                         </a:rPr>
-                        <a:t>Wed 01 Jul 2026  01:00 AM</a:t>
+                        <a:t>Wed 05 Aug 2026  05:00 AM</a:t>
                       </a:r>
                     </a:p>
                   </a:txBody>
@@ -4257,7 +4257,7 @@
                             <a:srgbClr val="E2E8F0"/>
                           </a:solidFill>
                         </a:rPr>
-                        <a:t>https://events.sumologic.com/welcomewebinarpm06302026-event-training</a:t>
+                        <a:t>https://events.sumologic.com/welcomewebinarpm08042026-event-training</a:t>
                       </a:r>
                     </a:p>
                   </a:txBody>
@@ -4343,7 +4343,7 @@
                             <a:srgbClr val="E2E8F0"/>
                           </a:solidFill>
                         </a:rPr>
-                        <a:t>Tue 30 Jun 2026  04:00 PM  →  07:00 PM</a:t>
+                        <a:t>Tue 04 Aug 2026  04:00 PM  →  07:00 PM</a:t>
                       </a:r>
                     </a:p>
                   </a:txBody>
@@ -4385,7 +4385,7 @@
                             <a:srgbClr val="E2E8F0"/>
                           </a:solidFill>
                         </a:rPr>
-                        <a:t>Wed 01 Jul 2026  11:00 AM</a:t>
+                        <a:t>Wed 05 Aug 2026  11:00 AM</a:t>
                       </a:r>
                     </a:p>
                   </a:txBody>
@@ -4427,7 +4427,7 @@
                             <a:srgbClr val="E2E8F0"/>
                           </a:solidFill>
                         </a:rPr>
-                        <a:t>Wed 01 Jul 2026  09:00 AM</a:t>
+                        <a:t>Wed 05 Aug 2026  09:00 AM</a:t>
                       </a:r>
                     </a:p>
                   </a:txBody>
@@ -4469,7 +4469,7 @@
                             <a:srgbClr val="E2E8F0"/>
                           </a:solidFill>
                         </a:rPr>
-                        <a:t>Wed 01 Jul 2026  07:00 AM</a:t>
+                        <a:t>Wed 05 Aug 2026  07:00 AM</a:t>
                       </a:r>
                     </a:p>
                   </a:txBody>
@@ -4511,7 +4511,7 @@
                             <a:srgbClr val="E2E8F0"/>
                           </a:solidFill>
                         </a:rPr>
-                        <a:t>https://events.sumologic.com/fundamentalspm06302026-event-training</a:t>
+                        <a:t>https://events.sumologic.com/fundamentalspm08042026-event-training</a:t>
                       </a:r>
                     </a:p>
                   </a:txBody>
@@ -4597,7 +4597,7 @@
                             <a:srgbClr val="E2E8F0"/>
                           </a:solidFill>
                         </a:rPr>
-                        <a:t>Wed 01 Jul 2026  07:00 AM  →  10:00 AM</a:t>
+                        <a:t>Wed 05 Aug 2026  07:00 AM  →  10:00 AM</a:t>
                       </a:r>
                     </a:p>
                   </a:txBody>
@@ -4639,7 +4639,7 @@
                             <a:srgbClr val="E2E8F0"/>
                           </a:solidFill>
                         </a:rPr>
-                        <a:t>Thu 02 Jul 2026  02:00 AM</a:t>
+                        <a:t>Thu 06 Aug 2026  02:00 AM</a:t>
                       </a:r>
                     </a:p>
                   </a:txBody>
@@ -4681,7 +4681,7 @@
                             <a:srgbClr val="E2E8F0"/>
                           </a:solidFill>
                         </a:rPr>
-                        <a:t>Thu 02 Jul 2026  12:00 AM</a:t>
+                        <a:t>Thu 06 Aug 2026  12:00 AM</a:t>
                       </a:r>
                     </a:p>
                   </a:txBody>
@@ -4723,7 +4723,7 @@
                             <a:srgbClr val="E2E8F0"/>
                           </a:solidFill>
                         </a:rPr>
-                        <a:t>Wed 01 Jul 2026  10:00 PM</a:t>
+                        <a:t>Wed 05 Aug 2026  10:00 PM</a:t>
                       </a:r>
                     </a:p>
                   </a:txBody>
@@ -4765,7 +4765,7 @@
                             <a:srgbClr val="E2E8F0"/>
                           </a:solidFill>
                         </a:rPr>
-                        <a:t>https://events.sumologic.com/searchmasteryam07012026-event-training</a:t>
+                        <a:t>https://events.sumologic.com/searchmasteryam08052026-event-training</a:t>
                       </a:r>
                     </a:p>
                   </a:txBody>
@@ -4851,7 +4851,7 @@
                             <a:srgbClr val="E2E8F0"/>
                           </a:solidFill>
                         </a:rPr>
-                        <a:t>Wed 01 Jul 2026  04:00 PM  →  07:00 PM</a:t>
+                        <a:t>Wed 05 Aug 2026  04:00 PM  →  07:00 PM</a:t>
                       </a:r>
                     </a:p>
                   </a:txBody>
@@ -4893,7 +4893,7 @@
                             <a:srgbClr val="E2E8F0"/>
                           </a:solidFill>
                         </a:rPr>
-                        <a:t>Thu 02 Jul 2026  11:00 AM</a:t>
+                        <a:t>Thu 06 Aug 2026  11:00 AM</a:t>
                       </a:r>
                     </a:p>
                   </a:txBody>
@@ -4935,7 +4935,7 @@
                             <a:srgbClr val="E2E8F0"/>
                           </a:solidFill>
                         </a:rPr>
-                        <a:t>Thu 02 Jul 2026  09:00 AM</a:t>
+                        <a:t>Thu 06 Aug 2026  09:00 AM</a:t>
                       </a:r>
                     </a:p>
                   </a:txBody>
@@ -4977,7 +4977,7 @@
                             <a:srgbClr val="E2E8F0"/>
                           </a:solidFill>
                         </a:rPr>
-                        <a:t>Thu 02 Jul 2026  07:00 AM</a:t>
+                        <a:t>Thu 06 Aug 2026  07:00 AM</a:t>
                       </a:r>
                     </a:p>
                   </a:txBody>
@@ -5019,7 +5019,7 @@
                             <a:srgbClr val="E2E8F0"/>
                           </a:solidFill>
                         </a:rPr>
-                        <a:t>https://events.sumologic.com/searchmasterypm07012026-event-training</a:t>
+                        <a:t>https://events.sumologic.com/searchmasterypm08052026-event-training</a:t>
                       </a:r>
                     </a:p>
                   </a:txBody>
@@ -5063,7 +5063,7 @@
                             <a:srgbClr val="E2E8F0"/>
                           </a:solidFill>
                         </a:rPr>
-                        <a:t>Best Practice for Query Efficiency AM</a:t>
+                        <a:t>Best Practices for Query Efficiency AM</a:t>
                       </a:r>
                     </a:p>
                   </a:txBody>
@@ -5105,7 +5105,7 @@
                             <a:srgbClr val="E2E8F0"/>
                           </a:solidFill>
                         </a:rPr>
-                        <a:t>Thu 02 Jul 2026  07:00 AM  →  08:30 AM</a:t>
+                        <a:t>Thu 06 Aug 2026  07:00 AM  →  08:30 AM</a:t>
                       </a:r>
                     </a:p>
                   </a:txBody>
@@ -5147,7 +5147,7 @@
                             <a:srgbClr val="E2E8F0"/>
                           </a:solidFill>
                         </a:rPr>
-                        <a:t>Fri 03 Jul 2026  02:00 AM</a:t>
+                        <a:t>Fri 07 Aug 2026  02:00 AM</a:t>
                       </a:r>
                     </a:p>
                   </a:txBody>
@@ -5189,7 +5189,7 @@
                             <a:srgbClr val="E2E8F0"/>
                           </a:solidFill>
                         </a:rPr>
-                        <a:t>Fri 03 Jul 2026  12:00 AM</a:t>
+                        <a:t>Fri 07 Aug 2026  12:00 AM</a:t>
                       </a:r>
                     </a:p>
                   </a:txBody>
@@ -5231,7 +5231,7 @@
                             <a:srgbClr val="E2E8F0"/>
                           </a:solidFill>
                         </a:rPr>
-                        <a:t>Thu 02 Jul 2026  10:00 PM</a:t>
+                        <a:t>Thu 06 Aug 2026  10:00 PM</a:t>
                       </a:r>
                     </a:p>
                   </a:txBody>
@@ -5273,7 +5273,7 @@
                             <a:srgbClr val="E2E8F0"/>
                           </a:solidFill>
                         </a:rPr>
-                        <a:t>https://events.sumologic.com/bp4qeam07022026-event-training</a:t>
+                        <a:t>https://events.sumologic.com/bp4qeam08062026-event-training</a:t>
                       </a:r>
                     </a:p>
                   </a:txBody>
@@ -5317,7 +5317,7 @@
                             <a:srgbClr val="E2E8F0"/>
                           </a:solidFill>
                         </a:rPr>
-                        <a:t>Best Practice for Query Efficiency PM</a:t>
+                        <a:t>Best Practices for Query Efficiency PM</a:t>
                       </a:r>
                     </a:p>
                   </a:txBody>
@@ -5359,7 +5359,7 @@
                             <a:srgbClr val="E2E8F0"/>
                           </a:solidFill>
                         </a:rPr>
-                        <a:t>Thu 02 Jul 2026  04:00 PM  →  05:25 PM</a:t>
+                        <a:t>Thu 06 Aug 2026  04:00 PM  →  05:28 PM</a:t>
                       </a:r>
                     </a:p>
                   </a:txBody>
@@ -5401,7 +5401,7 @@
                             <a:srgbClr val="E2E8F0"/>
                           </a:solidFill>
                         </a:rPr>
-                        <a:t>Fri 03 Jul 2026  11:00 AM</a:t>
+                        <a:t>Fri 07 Aug 2026  11:00 AM</a:t>
                       </a:r>
                     </a:p>
                   </a:txBody>
@@ -5443,7 +5443,7 @@
                             <a:srgbClr val="E2E8F0"/>
                           </a:solidFill>
                         </a:rPr>
-                        <a:t>Fri 03 Jul 2026  09:00 AM</a:t>
+                        <a:t>Fri 07 Aug 2026  09:00 AM</a:t>
                       </a:r>
                     </a:p>
                   </a:txBody>
@@ -5485,7 +5485,7 @@
                             <a:srgbClr val="E2E8F0"/>
                           </a:solidFill>
                         </a:rPr>
-                        <a:t>Fri 03 Jul 2026  07:00 AM</a:t>
+                        <a:t>Fri 07 Aug 2026  07:00 AM</a:t>
                       </a:r>
                     </a:p>
                   </a:txBody>
@@ -5527,7 +5527,7 @@
                             <a:srgbClr val="E2E8F0"/>
                           </a:solidFill>
                         </a:rPr>
-                        <a:t>https://events.sumologic.com/bp4qepm07022026-event-training</a:t>
+                        <a:t>https://events.sumologic.com/bp4qepm08062026-event-training</a:t>
                       </a:r>
                     </a:p>
                   </a:txBody>
@@ -5613,7 +5613,7 @@
                             <a:srgbClr val="E2E8F0"/>
                           </a:solidFill>
                         </a:rPr>
-                        <a:t>Tue 07 Jul 2026  07:00 AM  →  10:00 AM</a:t>
+                        <a:t>Tue 11 Aug 2026  07:00 AM  →  10:00 AM</a:t>
                       </a:r>
                     </a:p>
                   </a:txBody>
@@ -5655,7 +5655,7 @@
                             <a:srgbClr val="E2E8F0"/>
                           </a:solidFill>
                         </a:rPr>
-                        <a:t>Wed 08 Jul 2026  02:00 AM</a:t>
+                        <a:t>Wed 12 Aug 2026  02:00 AM</a:t>
                       </a:r>
                     </a:p>
                   </a:txBody>
@@ -5697,7 +5697,7 @@
                             <a:srgbClr val="E2E8F0"/>
                           </a:solidFill>
                         </a:rPr>
-                        <a:t>Wed 08 Jul 2026  12:00 AM</a:t>
+                        <a:t>Wed 12 Aug 2026  12:00 AM</a:t>
                       </a:r>
                     </a:p>
                   </a:txBody>
@@ -5739,7 +5739,7 @@
                             <a:srgbClr val="E2E8F0"/>
                           </a:solidFill>
                         </a:rPr>
-                        <a:t>Tue 07 Jul 2026  10:00 PM</a:t>
+                        <a:t>Tue 11 Aug 2026  10:00 PM</a:t>
                       </a:r>
                     </a:p>
                   </a:txBody>
@@ -5781,7 +5781,7 @@
                             <a:srgbClr val="E2E8F0"/>
                           </a:solidFill>
                         </a:rPr>
-                        <a:t>https://events.sumologic.com/administrationam07072026-event-training</a:t>
+                        <a:t>https://events.sumologic.com/administrationam08112026-event-training</a:t>
                       </a:r>
                     </a:p>
                   </a:txBody>
@@ -5867,7 +5867,7 @@
                             <a:srgbClr val="E2E8F0"/>
                           </a:solidFill>
                         </a:rPr>
-                        <a:t>Tue 07 Jul 2026  04:00 PM  →  07:00 PM</a:t>
+                        <a:t>Tue 11 Aug 2026  04:00 PM  →  07:00 PM</a:t>
                       </a:r>
                     </a:p>
                   </a:txBody>
@@ -5909,7 +5909,7 @@
                             <a:srgbClr val="E2E8F0"/>
                           </a:solidFill>
                         </a:rPr>
-                        <a:t>Wed 08 Jul 2026  11:00 AM</a:t>
+                        <a:t>Wed 12 Aug 2026  11:00 AM</a:t>
                       </a:r>
                     </a:p>
                   </a:txBody>
@@ -5951,7 +5951,7 @@
                             <a:srgbClr val="E2E8F0"/>
                           </a:solidFill>
                         </a:rPr>
-                        <a:t>Wed 08 Jul 2026  09:00 AM</a:t>
+                        <a:t>Wed 12 Aug 2026  09:00 AM</a:t>
                       </a:r>
                     </a:p>
                   </a:txBody>
@@ -5993,7 +5993,7 @@
                             <a:srgbClr val="E2E8F0"/>
                           </a:solidFill>
                         </a:rPr>
-                        <a:t>Wed 08 Jul 2026  07:00 AM</a:t>
+                        <a:t>Wed 12 Aug 2026  07:00 AM</a:t>
                       </a:r>
                     </a:p>
                   </a:txBody>
@@ -6035,7 +6035,7 @@
                             <a:srgbClr val="E2E8F0"/>
                           </a:solidFill>
                         </a:rPr>
-                        <a:t>https://events.sumologic.com/administrationpm07072026-event-training</a:t>
+                        <a:t>https://events.sumologic.com/administrationpm08112026-event-training</a:t>
                       </a:r>
                     </a:p>
                   </a:txBody>
@@ -6235,7 +6235,7 @@
                   <a:srgbClr val="00B4D8"/>
                 </a:solidFill>
               </a:rPr>
-              <a:t>Sumo Logic — Virtual Training Schedule   ·   08 Jul – 16 Jul 2026   (2/6)</a:t>
+              <a:t>Sumo Logic — Virtual Training Schedule   ·   12 Aug 2026 – 08 Sep 2026   (2/6)</a:t>
             </a:r>
           </a:p>
         </p:txBody>
@@ -6609,7 +6609,7 @@
                             <a:srgbClr val="E2E8F0"/>
                           </a:solidFill>
                         </a:rPr>
-                        <a:t>Wed 08 Jul 2026  07:00 AM  →  10:00 AM</a:t>
+                        <a:t>Wed 12 Aug 2026  07:00 AM  →  10:00 AM</a:t>
                       </a:r>
                     </a:p>
                   </a:txBody>
@@ -6651,7 +6651,7 @@
                             <a:srgbClr val="E2E8F0"/>
                           </a:solidFill>
                         </a:rPr>
-                        <a:t>Thu 09 Jul 2026  02:00 AM</a:t>
+                        <a:t>Thu 13 Aug 2026  02:00 AM</a:t>
                       </a:r>
                     </a:p>
                   </a:txBody>
@@ -6693,7 +6693,7 @@
                             <a:srgbClr val="E2E8F0"/>
                           </a:solidFill>
                         </a:rPr>
-                        <a:t>Thu 09 Jul 2026  12:00 AM</a:t>
+                        <a:t>Thu 13 Aug 2026  12:00 AM</a:t>
                       </a:r>
                     </a:p>
                   </a:txBody>
@@ -6735,7 +6735,7 @@
                             <a:srgbClr val="E2E8F0"/>
                           </a:solidFill>
                         </a:rPr>
-                        <a:t>Wed 08 Jul 2026  10:00 PM</a:t>
+                        <a:t>Wed 12 Aug 2026  10:00 PM</a:t>
                       </a:r>
                     </a:p>
                   </a:txBody>
@@ -6777,7 +6777,7 @@
                             <a:srgbClr val="E2E8F0"/>
                           </a:solidFill>
                         </a:rPr>
-                        <a:t>https://events.sumologic.com/metricanalyticsam07082026-event-training</a:t>
+                        <a:t>https://events.sumologic.com/metricsanalyticsam08122026-event-training</a:t>
                       </a:r>
                     </a:p>
                   </a:txBody>
@@ -6863,7 +6863,7 @@
                             <a:srgbClr val="E2E8F0"/>
                           </a:solidFill>
                         </a:rPr>
-                        <a:t>Wed 08 Jul 2026  04:00 PM  →  07:00 PM</a:t>
+                        <a:t>Wed 12 Aug 2026  04:00 PM  →  07:00 PM</a:t>
                       </a:r>
                     </a:p>
                   </a:txBody>
@@ -6905,7 +6905,7 @@
                             <a:srgbClr val="E2E8F0"/>
                           </a:solidFill>
                         </a:rPr>
-                        <a:t>Thu 09 Jul 2026  11:00 AM</a:t>
+                        <a:t>Thu 13 Aug 2026  11:00 AM</a:t>
                       </a:r>
                     </a:p>
                   </a:txBody>
@@ -6947,7 +6947,7 @@
                             <a:srgbClr val="E2E8F0"/>
                           </a:solidFill>
                         </a:rPr>
-                        <a:t>Thu 09 Jul 2026  09:00 AM</a:t>
+                        <a:t>Thu 13 Aug 2026  09:00 AM</a:t>
                       </a:r>
                     </a:p>
                   </a:txBody>
@@ -6989,7 +6989,7 @@
                             <a:srgbClr val="E2E8F0"/>
                           </a:solidFill>
                         </a:rPr>
-                        <a:t>Thu 09 Jul 2026  07:00 AM</a:t>
+                        <a:t>Thu 13 Aug 2026  07:00 AM</a:t>
                       </a:r>
                     </a:p>
                   </a:txBody>
@@ -7031,7 +7031,7 @@
                             <a:srgbClr val="E2E8F0"/>
                           </a:solidFill>
                         </a:rPr>
-                        <a:t>https://events.sumologic.com/metricanalyticspm07082026-event-training</a:t>
+                        <a:t>https://events.sumologic.com/metricsanalyticspm08122026-event-training</a:t>
                       </a:r>
                     </a:p>
                   </a:txBody>
@@ -7075,7 +7075,7 @@
                             <a:srgbClr val="E2E8F0"/>
                           </a:solidFill>
                         </a:rPr>
-                        <a:t>Mobot Essentials AM</a:t>
+                        <a:t>Hands on with Mobot and Dojo AI AM</a:t>
                       </a:r>
                     </a:p>
                   </a:txBody>
@@ -7117,7 +7117,7 @@
                             <a:srgbClr val="E2E8F0"/>
                           </a:solidFill>
                         </a:rPr>
-                        <a:t>Thu 09 Jul 2026  07:00 AM  →  08:30 AM</a:t>
+                        <a:t>Thu 13 Aug 2026  07:00 AM  →  08:30 AM</a:t>
                       </a:r>
                     </a:p>
                   </a:txBody>
@@ -7159,7 +7159,7 @@
                             <a:srgbClr val="E2E8F0"/>
                           </a:solidFill>
                         </a:rPr>
-                        <a:t>Fri 10 Jul 2026  02:00 AM</a:t>
+                        <a:t>Fri 14 Aug 2026  02:00 AM</a:t>
                       </a:r>
                     </a:p>
                   </a:txBody>
@@ -7201,7 +7201,7 @@
                             <a:srgbClr val="E2E8F0"/>
                           </a:solidFill>
                         </a:rPr>
-                        <a:t>Fri 10 Jul 2026  12:00 AM</a:t>
+                        <a:t>Fri 14 Aug 2026  12:00 AM</a:t>
                       </a:r>
                     </a:p>
                   </a:txBody>
@@ -7243,7 +7243,7 @@
                             <a:srgbClr val="E2E8F0"/>
                           </a:solidFill>
                         </a:rPr>
-                        <a:t>Thu 09 Jul 2026  10:00 PM</a:t>
+                        <a:t>Thu 13 Aug 2026  10:00 PM</a:t>
                       </a:r>
                     </a:p>
                   </a:txBody>
@@ -7285,7 +7285,7 @@
                             <a:srgbClr val="E2E8F0"/>
                           </a:solidFill>
                         </a:rPr>
-                        <a:t>https://events.sumologic.com/mobotam07092026-event-training</a:t>
+                        <a:t>https://events.sumologic.com/mobotessentialsam08132026-event-training</a:t>
                       </a:r>
                     </a:p>
                   </a:txBody>
@@ -7329,7 +7329,7 @@
                             <a:srgbClr val="E2E8F0"/>
                           </a:solidFill>
                         </a:rPr>
-                        <a:t>Mobot Essentials PM</a:t>
+                        <a:t>Hands on with Mobot and Dojo AI PM</a:t>
                       </a:r>
                     </a:p>
                   </a:txBody>
@@ -7371,7 +7371,7 @@
                             <a:srgbClr val="E2E8F0"/>
                           </a:solidFill>
                         </a:rPr>
-                        <a:t>Thu 09 Jul 2026  04:00 PM  →  05:30 PM</a:t>
+                        <a:t>Thu 13 Aug 2026  04:00 PM  →  05:30 PM</a:t>
                       </a:r>
                     </a:p>
                   </a:txBody>
@@ -7413,7 +7413,7 @@
                             <a:srgbClr val="E2E8F0"/>
                           </a:solidFill>
                         </a:rPr>
-                        <a:t>Fri 10 Jul 2026  11:00 AM</a:t>
+                        <a:t>Fri 14 Aug 2026  11:00 AM</a:t>
                       </a:r>
                     </a:p>
                   </a:txBody>
@@ -7455,7 +7455,7 @@
                             <a:srgbClr val="E2E8F0"/>
                           </a:solidFill>
                         </a:rPr>
-                        <a:t>Fri 10 Jul 2026  09:00 AM</a:t>
+                        <a:t>Fri 14 Aug 2026  09:00 AM</a:t>
                       </a:r>
                     </a:p>
                   </a:txBody>
@@ -7497,7 +7497,7 @@
                             <a:srgbClr val="E2E8F0"/>
                           </a:solidFill>
                         </a:rPr>
-                        <a:t>Fri 10 Jul 2026  07:00 AM</a:t>
+                        <a:t>Fri 14 Aug 2026  07:00 AM</a:t>
                       </a:r>
                     </a:p>
                   </a:txBody>
@@ -7539,7 +7539,7 @@
                             <a:srgbClr val="E2E8F0"/>
                           </a:solidFill>
                         </a:rPr>
-                        <a:t>https://events.sumologic.com/mobotessentialspm07092026-event-training</a:t>
+                        <a:t>https://events.sumologic.com/mobotessentialspm08132026-event-training</a:t>
                       </a:r>
                     </a:p>
                   </a:txBody>
@@ -7583,7 +7583,7 @@
                             <a:srgbClr val="E2E8F0"/>
                           </a:solidFill>
                         </a:rPr>
-                        <a:t>Essential Cloud SIEM skills for SOC Analysts AM</a:t>
+                        <a:t>Essential SIEM Skills for SOC Analysts AM</a:t>
                       </a:r>
                     </a:p>
                   </a:txBody>
@@ -7625,7 +7625,7 @@
                             <a:srgbClr val="E2E8F0"/>
                           </a:solidFill>
                         </a:rPr>
-                        <a:t>Tue 14 Jul 2026  07:00 AM  →  08:30 AM</a:t>
+                        <a:t>Tue 18 Aug 2026  07:00 AM  →  08:30 AM</a:t>
                       </a:r>
                     </a:p>
                   </a:txBody>
@@ -7667,7 +7667,7 @@
                             <a:srgbClr val="E2E8F0"/>
                           </a:solidFill>
                         </a:rPr>
-                        <a:t>Wed 15 Jul 2026  02:00 AM</a:t>
+                        <a:t>Wed 19 Aug 2026  02:00 AM</a:t>
                       </a:r>
                     </a:p>
                   </a:txBody>
@@ -7709,7 +7709,7 @@
                             <a:srgbClr val="E2E8F0"/>
                           </a:solidFill>
                         </a:rPr>
-                        <a:t>Wed 15 Jul 2026  12:00 AM</a:t>
+                        <a:t>Wed 19 Aug 2026  12:00 AM</a:t>
                       </a:r>
                     </a:p>
                   </a:txBody>
@@ -7751,7 +7751,7 @@
                             <a:srgbClr val="E2E8F0"/>
                           </a:solidFill>
                         </a:rPr>
-                        <a:t>Tue 14 Jul 2026  10:00 PM</a:t>
+                        <a:t>Tue 18 Aug 2026  10:00 PM</a:t>
                       </a:r>
                     </a:p>
                   </a:txBody>
@@ -7793,7 +7793,7 @@
                             <a:srgbClr val="E2E8F0"/>
                           </a:solidFill>
                         </a:rPr>
-                        <a:t>https://events.sumologic.com/esscloudsiemam07142026-event-training</a:t>
+                        <a:t>https://events.sumologic.com/esscloudsiemam08182026-event-training</a:t>
                       </a:r>
                     </a:p>
                   </a:txBody>
@@ -7837,7 +7837,7 @@
                             <a:srgbClr val="E2E8F0"/>
                           </a:solidFill>
                         </a:rPr>
-                        <a:t>Essential Cloud SIEM skills for SOC Analysts PM</a:t>
+                        <a:t>Essential SIEM Skills for SOC Analysts PM</a:t>
                       </a:r>
                     </a:p>
                   </a:txBody>
@@ -7879,7 +7879,7 @@
                             <a:srgbClr val="E2E8F0"/>
                           </a:solidFill>
                         </a:rPr>
-                        <a:t>Tue 14 Jul 2026  04:00 PM  →  05:30 PM</a:t>
+                        <a:t>Tue 18 Aug 2026  04:00 PM  →  05:30 PM</a:t>
                       </a:r>
                     </a:p>
                   </a:txBody>
@@ -7921,7 +7921,7 @@
                             <a:srgbClr val="E2E8F0"/>
                           </a:solidFill>
                         </a:rPr>
-                        <a:t>Wed 15 Jul 2026  11:00 AM</a:t>
+                        <a:t>Wed 19 Aug 2026  11:00 AM</a:t>
                       </a:r>
                     </a:p>
                   </a:txBody>
@@ -7963,7 +7963,7 @@
                             <a:srgbClr val="E2E8F0"/>
                           </a:solidFill>
                         </a:rPr>
-                        <a:t>Wed 15 Jul 2026  09:00 AM</a:t>
+                        <a:t>Wed 19 Aug 2026  09:00 AM</a:t>
                       </a:r>
                     </a:p>
                   </a:txBody>
@@ -8005,7 +8005,7 @@
                             <a:srgbClr val="E2E8F0"/>
                           </a:solidFill>
                         </a:rPr>
-                        <a:t>Wed 15 Jul 2026  07:00 AM</a:t>
+                        <a:t>Wed 19 Aug 2026  07:00 AM</a:t>
                       </a:r>
                     </a:p>
                   </a:txBody>
@@ -8047,7 +8047,7 @@
                             <a:srgbClr val="E2E8F0"/>
                           </a:solidFill>
                         </a:rPr>
-                        <a:t>https://events.sumologic.com/esscloudsiem07142026-event-training</a:t>
+                        <a:t>https://events.sumologic.com/esscloudsiempm08182026-event-training</a:t>
                       </a:r>
                     </a:p>
                   </a:txBody>
@@ -8133,7 +8133,7 @@
                             <a:srgbClr val="E2E8F0"/>
                           </a:solidFill>
                         </a:rPr>
-                        <a:t>Wed 15 Jul 2026  07:00 AM  →  10:00 AM</a:t>
+                        <a:t>Wed 19 Aug 2026  07:00 AM  →  10:00 AM</a:t>
                       </a:r>
                     </a:p>
                   </a:txBody>
@@ -8175,7 +8175,7 @@
                             <a:srgbClr val="E2E8F0"/>
                           </a:solidFill>
                         </a:rPr>
-                        <a:t>Thu 16 Jul 2026  02:00 AM</a:t>
+                        <a:t>Thu 20 Aug 2026  02:00 AM</a:t>
                       </a:r>
                     </a:p>
                   </a:txBody>
@@ -8217,7 +8217,7 @@
                             <a:srgbClr val="E2E8F0"/>
                           </a:solidFill>
                         </a:rPr>
-                        <a:t>Thu 16 Jul 2026  12:00 AM</a:t>
+                        <a:t>Thu 20 Aug 2026  12:00 AM</a:t>
                       </a:r>
                     </a:p>
                   </a:txBody>
@@ -8259,7 +8259,7 @@
                             <a:srgbClr val="E2E8F0"/>
                           </a:solidFill>
                         </a:rPr>
-                        <a:t>Wed 15 Jul 2026  10:00 PM</a:t>
+                        <a:t>Wed 19 Aug 2026  10:00 PM</a:t>
                       </a:r>
                     </a:p>
                   </a:txBody>
@@ -8301,7 +8301,7 @@
                             <a:srgbClr val="E2E8F0"/>
                           </a:solidFill>
                         </a:rPr>
-                        <a:t>https://events.sumologic.com/cloudsiemam07152026-event-training</a:t>
+                        <a:t>https://events.sumologic.com/cloudsiemam08192026-event-training</a:t>
                       </a:r>
                     </a:p>
                   </a:txBody>
@@ -8387,7 +8387,7 @@
                             <a:srgbClr val="E2E8F0"/>
                           </a:solidFill>
                         </a:rPr>
-                        <a:t>Wed 15 Jul 2026  04:00 PM  →  07:00 PM</a:t>
+                        <a:t>Wed 19 Aug 2026  04:00 PM  →  07:00 PM</a:t>
                       </a:r>
                     </a:p>
                   </a:txBody>
@@ -8429,7 +8429,7 @@
                             <a:srgbClr val="E2E8F0"/>
                           </a:solidFill>
                         </a:rPr>
-                        <a:t>Thu 16 Jul 2026  11:00 AM</a:t>
+                        <a:t>Thu 20 Aug 2026  11:00 AM</a:t>
                       </a:r>
                     </a:p>
                   </a:txBody>
@@ -8471,7 +8471,7 @@
                             <a:srgbClr val="E2E8F0"/>
                           </a:solidFill>
                         </a:rPr>
-                        <a:t>Thu 16 Jul 2026  09:00 AM</a:t>
+                        <a:t>Thu 20 Aug 2026  09:00 AM</a:t>
                       </a:r>
                     </a:p>
                   </a:txBody>
@@ -8513,7 +8513,7 @@
                             <a:srgbClr val="E2E8F0"/>
                           </a:solidFill>
                         </a:rPr>
-                        <a:t>Thu 16 Jul 2026  07:00 AM</a:t>
+                        <a:t>Thu 20 Aug 2026  07:00 AM</a:t>
                       </a:r>
                     </a:p>
                   </a:txBody>
@@ -8555,7 +8555,7 @@
                             <a:srgbClr val="E2E8F0"/>
                           </a:solidFill>
                         </a:rPr>
-                        <a:t>https://events.sumologic.com/cloudsiempm07152026-event-training</a:t>
+                        <a:t>https://events.sumologic.com/cloudsiempm08192026-event-training</a:t>
                       </a:r>
                     </a:p>
                   </a:txBody>
@@ -8599,7 +8599,7 @@
                             <a:srgbClr val="E2E8F0"/>
                           </a:solidFill>
                         </a:rPr>
-                        <a:t>Automation AM</a:t>
+                        <a:t>Welcome Webinar AM</a:t>
                       </a:r>
                     </a:p>
                   </a:txBody>
@@ -8641,7 +8641,7 @@
                             <a:srgbClr val="E2E8F0"/>
                           </a:solidFill>
                         </a:rPr>
-                        <a:t>Thu 16 Jul 2026  07:00 AM  →  08:30 AM</a:t>
+                        <a:t>Tue 08 Sep 2026  05:00 AM  →  06:00 AM</a:t>
                       </a:r>
                     </a:p>
                   </a:txBody>
@@ -8683,7 +8683,7 @@
                             <a:srgbClr val="E2E8F0"/>
                           </a:solidFill>
                         </a:rPr>
-                        <a:t>Fri 17 Jul 2026  02:00 AM</a:t>
+                        <a:t>Wed 09 Sep 2026  12:00 AM</a:t>
                       </a:r>
                     </a:p>
                   </a:txBody>
@@ -8725,7 +8725,7 @@
                             <a:srgbClr val="E2E8F0"/>
                           </a:solidFill>
                         </a:rPr>
-                        <a:t>Fri 17 Jul 2026  12:00 AM</a:t>
+                        <a:t>Tue 08 Sep 2026  10:00 PM</a:t>
                       </a:r>
                     </a:p>
                   </a:txBody>
@@ -8767,7 +8767,7 @@
                             <a:srgbClr val="E2E8F0"/>
                           </a:solidFill>
                         </a:rPr>
-                        <a:t>Thu 16 Jul 2026  10:00 PM</a:t>
+                        <a:t>Tue 08 Sep 2026  08:00 PM</a:t>
                       </a:r>
                     </a:p>
                   </a:txBody>
@@ -8809,7 +8809,7 @@
                             <a:srgbClr val="E2E8F0"/>
                           </a:solidFill>
                         </a:rPr>
-                        <a:t>https://events.sumologic.com/automationam07162026-event-training</a:t>
+                        <a:t>https://events.sumologic.com/welcomewebinaram09082026-event-training</a:t>
                       </a:r>
                     </a:p>
                   </a:txBody>
@@ -8853,7 +8853,7 @@
                             <a:srgbClr val="E2E8F0"/>
                           </a:solidFill>
                         </a:rPr>
-                        <a:t>Automation PM</a:t>
+                        <a:t>Fundamentals AM</a:t>
                       </a:r>
                     </a:p>
                   </a:txBody>
@@ -8895,7 +8895,7 @@
                             <a:srgbClr val="E2E8F0"/>
                           </a:solidFill>
                         </a:rPr>
-                        <a:t>Thu 16 Jul 2026  04:00 PM  →  05:30 PM</a:t>
+                        <a:t>Tue 08 Sep 2026  07:00 AM  →  10:00 AM</a:t>
                       </a:r>
                     </a:p>
                   </a:txBody>
@@ -8937,7 +8937,7 @@
                             <a:srgbClr val="E2E8F0"/>
                           </a:solidFill>
                         </a:rPr>
-                        <a:t>Fri 17 Jul 2026  11:00 AM</a:t>
+                        <a:t>Wed 09 Sep 2026  02:00 AM</a:t>
                       </a:r>
                     </a:p>
                   </a:txBody>
@@ -8979,7 +8979,7 @@
                             <a:srgbClr val="E2E8F0"/>
                           </a:solidFill>
                         </a:rPr>
-                        <a:t>Fri 17 Jul 2026  09:00 AM</a:t>
+                        <a:t>Wed 09 Sep 2026  12:00 AM</a:t>
                       </a:r>
                     </a:p>
                   </a:txBody>
@@ -9021,7 +9021,7 @@
                             <a:srgbClr val="E2E8F0"/>
                           </a:solidFill>
                         </a:rPr>
-                        <a:t>Fri 17 Jul 2026  07:00 AM</a:t>
+                        <a:t>Tue 08 Sep 2026  10:00 PM</a:t>
                       </a:r>
                     </a:p>
                   </a:txBody>
@@ -9063,7 +9063,7 @@
                             <a:srgbClr val="E2E8F0"/>
                           </a:solidFill>
                         </a:rPr>
-                        <a:t>https://events.sumologic.com/automationpm07162026-event-training</a:t>
+                        <a:t>https://events.sumologic.com/fundamentalsam09082026-event-training</a:t>
                       </a:r>
                     </a:p>
                   </a:txBody>
@@ -9263,7 +9263,7 @@
                   <a:srgbClr val="00B4D8"/>
                 </a:solidFill>
               </a:rPr>
-              <a:t>Sumo Logic — Virtual Training Schedule   ·   04 Aug – 11 Aug 2026   (3/6)</a:t>
+              <a:t>Sumo Logic — Virtual Training Schedule   ·   08 Sep – 16 Sep 2026   (3/6)</a:t>
             </a:r>
           </a:p>
         </p:txBody>
@@ -9595,7 +9595,7 @@
                             <a:srgbClr val="E2E8F0"/>
                           </a:solidFill>
                         </a:rPr>
-                        <a:t>Welcome Webinar AM</a:t>
+                        <a:t>Welcome Webinar PM</a:t>
                       </a:r>
                     </a:p>
                   </a:txBody>
@@ -9637,7 +9637,7 @@
                             <a:srgbClr val="E2E8F0"/>
                           </a:solidFill>
                         </a:rPr>
-                        <a:t>Tue 04 Aug 2026  05:00 AM  →  06:00 AM</a:t>
+                        <a:t>Tue 08 Sep 2026  02:00 PM  →  03:00 PM</a:t>
                       </a:r>
                     </a:p>
                   </a:txBody>
@@ -9679,7 +9679,7 @@
                             <a:srgbClr val="E2E8F0"/>
                           </a:solidFill>
                         </a:rPr>
-                        <a:t>Wed 05 Aug 2026  12:00 AM</a:t>
+                        <a:t>Wed 09 Sep 2026  09:00 AM</a:t>
                       </a:r>
                     </a:p>
                   </a:txBody>
@@ -9721,7 +9721,7 @@
                             <a:srgbClr val="E2E8F0"/>
                           </a:solidFill>
                         </a:rPr>
-                        <a:t>Tue 04 Aug 2026  10:00 PM</a:t>
+                        <a:t>Wed 09 Sep 2026  07:00 AM</a:t>
                       </a:r>
                     </a:p>
                   </a:txBody>
@@ -9763,7 +9763,7 @@
                             <a:srgbClr val="E2E8F0"/>
                           </a:solidFill>
                         </a:rPr>
-                        <a:t>Tue 04 Aug 2026  08:00 PM</a:t>
+                        <a:t>Wed 09 Sep 2026  05:00 AM</a:t>
                       </a:r>
                     </a:p>
                   </a:txBody>
@@ -9805,7 +9805,7 @@
                             <a:srgbClr val="E2E8F0"/>
                           </a:solidFill>
                         </a:rPr>
-                        <a:t>https://events.sumologic.com/welcomewebinaram08042026-event-training</a:t>
+                        <a:t>https://events.sumologic.com/welcomewebinarpm09082026-event-training</a:t>
                       </a:r>
                     </a:p>
                   </a:txBody>
@@ -9849,7 +9849,7 @@
                             <a:srgbClr val="E2E8F0"/>
                           </a:solidFill>
                         </a:rPr>
-                        <a:t>Fundamentals AM</a:t>
+                        <a:t>Fundamentals PM</a:t>
                       </a:r>
                     </a:p>
                   </a:txBody>
@@ -9891,7 +9891,7 @@
                             <a:srgbClr val="E2E8F0"/>
                           </a:solidFill>
                         </a:rPr>
-                        <a:t>Tue 04 Aug 2026  07:00 AM  →  10:00 AM</a:t>
+                        <a:t>Tue 08 Sep 2026  04:00 PM  →  07:00 PM</a:t>
                       </a:r>
                     </a:p>
                   </a:txBody>
@@ -9933,7 +9933,7 @@
                             <a:srgbClr val="E2E8F0"/>
                           </a:solidFill>
                         </a:rPr>
-                        <a:t>Wed 05 Aug 2026  02:00 AM</a:t>
+                        <a:t>Wed 09 Sep 2026  11:00 AM</a:t>
                       </a:r>
                     </a:p>
                   </a:txBody>
@@ -9975,7 +9975,7 @@
                             <a:srgbClr val="E2E8F0"/>
                           </a:solidFill>
                         </a:rPr>
-                        <a:t>Wed 05 Aug 2026  12:00 AM</a:t>
+                        <a:t>Wed 09 Sep 2026  09:00 AM</a:t>
                       </a:r>
                     </a:p>
                   </a:txBody>
@@ -10017,7 +10017,7 @@
                             <a:srgbClr val="E2E8F0"/>
                           </a:solidFill>
                         </a:rPr>
-                        <a:t>Tue 04 Aug 2026  10:00 PM</a:t>
+                        <a:t>Wed 09 Sep 2026  07:00 AM</a:t>
                       </a:r>
                     </a:p>
                   </a:txBody>
@@ -10059,7 +10059,7 @@
                             <a:srgbClr val="E2E8F0"/>
                           </a:solidFill>
                         </a:rPr>
-                        <a:t>https://events.sumologic.com/fundamentalsam08042026-event-training</a:t>
+                        <a:t>https://events.sumologic.com/fundamentalspm09082026-event-training</a:t>
                       </a:r>
                     </a:p>
                   </a:txBody>
@@ -10103,7 +10103,7 @@
                             <a:srgbClr val="E2E8F0"/>
                           </a:solidFill>
                         </a:rPr>
-                        <a:t>Welcome Webinars PM</a:t>
+                        <a:t>Search Mastery AM</a:t>
                       </a:r>
                     </a:p>
                   </a:txBody>
@@ -10145,7 +10145,7 @@
                             <a:srgbClr val="E2E8F0"/>
                           </a:solidFill>
                         </a:rPr>
-                        <a:t>Tue 04 Aug 2026  02:00 PM  →  03:00 PM</a:t>
+                        <a:t>Wed 09 Sep 2026  07:00 AM  →  10:00 AM</a:t>
                       </a:r>
                     </a:p>
                   </a:txBody>
@@ -10187,7 +10187,7 @@
                             <a:srgbClr val="E2E8F0"/>
                           </a:solidFill>
                         </a:rPr>
-                        <a:t>Wed 05 Aug 2026  09:00 AM</a:t>
+                        <a:t>Thu 10 Sep 2026  02:00 AM</a:t>
                       </a:r>
                     </a:p>
                   </a:txBody>
@@ -10229,7 +10229,7 @@
                             <a:srgbClr val="E2E8F0"/>
                           </a:solidFill>
                         </a:rPr>
-                        <a:t>Wed 05 Aug 2026  07:00 AM</a:t>
+                        <a:t>Thu 10 Sep 2026  12:00 AM</a:t>
                       </a:r>
                     </a:p>
                   </a:txBody>
@@ -10271,7 +10271,7 @@
                             <a:srgbClr val="E2E8F0"/>
                           </a:solidFill>
                         </a:rPr>
-                        <a:t>Wed 05 Aug 2026  05:00 AM</a:t>
+                        <a:t>Wed 09 Sep 2026  10:00 PM</a:t>
                       </a:r>
                     </a:p>
                   </a:txBody>
@@ -10313,7 +10313,7 @@
                             <a:srgbClr val="E2E8F0"/>
                           </a:solidFill>
                         </a:rPr>
-                        <a:t>https://events.sumologic.com/welcomewebinarpm08042026-event-training</a:t>
+                        <a:t>https://events.sumologic.com/searchmasteryam09092026-event-training</a:t>
                       </a:r>
                     </a:p>
                   </a:txBody>
@@ -10357,7 +10357,7 @@
                             <a:srgbClr val="E2E8F0"/>
                           </a:solidFill>
                         </a:rPr>
-                        <a:t>Fundamentals PM</a:t>
+                        <a:t>Search Mastery PM</a:t>
                       </a:r>
                     </a:p>
                   </a:txBody>
@@ -10399,7 +10399,7 @@
                             <a:srgbClr val="E2E8F0"/>
                           </a:solidFill>
                         </a:rPr>
-                        <a:t>Tue 04 Aug 2026  04:00 PM  →  07:00 PM</a:t>
+                        <a:t>Wed 09 Sep 2026  04:00 PM  →  07:00 PM</a:t>
                       </a:r>
                     </a:p>
                   </a:txBody>
@@ -10441,7 +10441,7 @@
                             <a:srgbClr val="E2E8F0"/>
                           </a:solidFill>
                         </a:rPr>
-                        <a:t>Wed 05 Aug 2026  11:00 AM</a:t>
+                        <a:t>Thu 10 Sep 2026  11:00 AM</a:t>
                       </a:r>
                     </a:p>
                   </a:txBody>
@@ -10483,7 +10483,7 @@
                             <a:srgbClr val="E2E8F0"/>
                           </a:solidFill>
                         </a:rPr>
-                        <a:t>Wed 05 Aug 2026  09:00 AM</a:t>
+                        <a:t>Thu 10 Sep 2026  09:00 AM</a:t>
                       </a:r>
                     </a:p>
                   </a:txBody>
@@ -10525,7 +10525,7 @@
                             <a:srgbClr val="E2E8F0"/>
                           </a:solidFill>
                         </a:rPr>
-                        <a:t>Wed 05 Aug 2026  07:00 AM</a:t>
+                        <a:t>Thu 10 Sep 2026  07:00 AM</a:t>
                       </a:r>
                     </a:p>
                   </a:txBody>
@@ -10567,7 +10567,7 @@
                             <a:srgbClr val="E2E8F0"/>
                           </a:solidFill>
                         </a:rPr>
-                        <a:t>https://events.sumologic.com/fundamentalspm08042026-event-training</a:t>
+                        <a:t>https://events.sumologic.com/searchmasterypm09092026-event-training</a:t>
                       </a:r>
                     </a:p>
                   </a:txBody>
@@ -10611,7 +10611,7 @@
                             <a:srgbClr val="E2E8F0"/>
                           </a:solidFill>
                         </a:rPr>
-                        <a:t>Search Mastery AM</a:t>
+                        <a:t>Best Practices for Query Efficiency AM</a:t>
                       </a:r>
                     </a:p>
                   </a:txBody>
@@ -10653,7 +10653,7 @@
                             <a:srgbClr val="E2E8F0"/>
                           </a:solidFill>
                         </a:rPr>
-                        <a:t>Wed 05 Aug 2026  07:00 AM  →  10:00 AM</a:t>
+                        <a:t>Thu 10 Sep 2026  07:00 AM  →  08:30 AM</a:t>
                       </a:r>
                     </a:p>
                   </a:txBody>
@@ -10695,7 +10695,7 @@
                             <a:srgbClr val="E2E8F0"/>
                           </a:solidFill>
                         </a:rPr>
-                        <a:t>Thu 06 Aug 2026  02:00 AM</a:t>
+                        <a:t>Fri 11 Sep 2026  02:00 AM</a:t>
                       </a:r>
                     </a:p>
                   </a:txBody>
@@ -10737,7 +10737,7 @@
                             <a:srgbClr val="E2E8F0"/>
                           </a:solidFill>
                         </a:rPr>
-                        <a:t>Thu 06 Aug 2026  12:00 AM</a:t>
+                        <a:t>Fri 11 Sep 2026  12:00 AM</a:t>
                       </a:r>
                     </a:p>
                   </a:txBody>
@@ -10779,7 +10779,7 @@
                             <a:srgbClr val="E2E8F0"/>
                           </a:solidFill>
                         </a:rPr>
-                        <a:t>Wed 05 Aug 2026  10:00 PM</a:t>
+                        <a:t>Thu 10 Sep 2026  10:00 PM</a:t>
                       </a:r>
                     </a:p>
                   </a:txBody>
@@ -10821,7 +10821,7 @@
                             <a:srgbClr val="E2E8F0"/>
                           </a:solidFill>
                         </a:rPr>
-                        <a:t>https://events.sumologic.com/searchmasteryam08052026-event-training</a:t>
+                        <a:t>https://events.sumologic.com/bp4qeam09102026-event-training</a:t>
                       </a:r>
                     </a:p>
                   </a:txBody>
@@ -10865,7 +10865,7 @@
                             <a:srgbClr val="E2E8F0"/>
                           </a:solidFill>
                         </a:rPr>
-                        <a:t>Search Mastery PM</a:t>
+                        <a:t>Best Practices for Query Efficiency PM</a:t>
                       </a:r>
                     </a:p>
                   </a:txBody>
@@ -10907,7 +10907,7 @@
                             <a:srgbClr val="E2E8F0"/>
                           </a:solidFill>
                         </a:rPr>
-                        <a:t>Wed 05 Aug 2026  04:00 PM  →  07:00 PM</a:t>
+                        <a:t>Thu 10 Sep 2026  04:00 PM  →  05:30 PM</a:t>
                       </a:r>
                     </a:p>
                   </a:txBody>
@@ -10949,7 +10949,7 @@
                             <a:srgbClr val="E2E8F0"/>
                           </a:solidFill>
                         </a:rPr>
-                        <a:t>Thu 06 Aug 2026  11:00 AM</a:t>
+                        <a:t>Fri 11 Sep 2026  11:00 AM</a:t>
                       </a:r>
                     </a:p>
                   </a:txBody>
@@ -10991,7 +10991,7 @@
                             <a:srgbClr val="E2E8F0"/>
                           </a:solidFill>
                         </a:rPr>
-                        <a:t>Thu 06 Aug 2026  09:00 AM</a:t>
+                        <a:t>Fri 11 Sep 2026  09:00 AM</a:t>
                       </a:r>
                     </a:p>
                   </a:txBody>
@@ -11033,7 +11033,7 @@
                             <a:srgbClr val="E2E8F0"/>
                           </a:solidFill>
                         </a:rPr>
-                        <a:t>Thu 06 Aug 2026  07:00 AM</a:t>
+                        <a:t>Fri 11 Sep 2026  07:00 AM</a:t>
                       </a:r>
                     </a:p>
                   </a:txBody>
@@ -11075,7 +11075,7 @@
                             <a:srgbClr val="E2E8F0"/>
                           </a:solidFill>
                         </a:rPr>
-                        <a:t>https://events.sumologic.com/searchmasterypm08052026-event-training</a:t>
+                        <a:t>https://events.sumologic.com/bp4qepm09102026-event-training</a:t>
                       </a:r>
                     </a:p>
                   </a:txBody>
@@ -11119,7 +11119,7 @@
                             <a:srgbClr val="E2E8F0"/>
                           </a:solidFill>
                         </a:rPr>
-                        <a:t>Best Practices for Query Efficiency AM</a:t>
+                        <a:t>Administration AM</a:t>
                       </a:r>
                     </a:p>
                   </a:txBody>
@@ -11161,7 +11161,7 @@
                             <a:srgbClr val="E2E8F0"/>
                           </a:solidFill>
                         </a:rPr>
-                        <a:t>Thu 06 Aug 2026  07:00 AM  →  08:30 AM</a:t>
+                        <a:t>Tue 15 Sep 2026  07:00 AM  →  10:00 AM</a:t>
                       </a:r>
                     </a:p>
                   </a:txBody>
@@ -11203,7 +11203,7 @@
                             <a:srgbClr val="E2E8F0"/>
                           </a:solidFill>
                         </a:rPr>
-                        <a:t>Fri 07 Aug 2026  02:00 AM</a:t>
+                        <a:t>Wed 16 Sep 2026  02:00 AM</a:t>
                       </a:r>
                     </a:p>
                   </a:txBody>
@@ -11245,7 +11245,7 @@
                             <a:srgbClr val="E2E8F0"/>
                           </a:solidFill>
                         </a:rPr>
-                        <a:t>Fri 07 Aug 2026  12:00 AM</a:t>
+                        <a:t>Wed 16 Sep 2026  12:00 AM</a:t>
                       </a:r>
                     </a:p>
                   </a:txBody>
@@ -11287,7 +11287,7 @@
                             <a:srgbClr val="E2E8F0"/>
                           </a:solidFill>
                         </a:rPr>
-                        <a:t>Thu 06 Aug 2026  10:00 PM</a:t>
+                        <a:t>Tue 15 Sep 2026  10:00 PM</a:t>
                       </a:r>
                     </a:p>
                   </a:txBody>
@@ -11329,7 +11329,7 @@
                             <a:srgbClr val="E2E8F0"/>
                           </a:solidFill>
                         </a:rPr>
-                        <a:t>https://events.sumologic.com/bp4qeam08062026-event-training</a:t>
+                        <a:t>https://events.sumologic.com/administrationam09152026-event-training</a:t>
                       </a:r>
                     </a:p>
                   </a:txBody>
@@ -11373,7 +11373,7 @@
                             <a:srgbClr val="E2E8F0"/>
                           </a:solidFill>
                         </a:rPr>
-                        <a:t>Best Practices for Query Efficiency PM</a:t>
+                        <a:t>Administration PM</a:t>
                       </a:r>
                     </a:p>
                   </a:txBody>
@@ -11415,7 +11415,7 @@
                             <a:srgbClr val="E2E8F0"/>
                           </a:solidFill>
                         </a:rPr>
-                        <a:t>Thu 06 Aug 2026  04:00 PM  →  05:28 PM</a:t>
+                        <a:t>Tue 15 Sep 2026  04:00 PM  →  07:00 PM</a:t>
                       </a:r>
                     </a:p>
                   </a:txBody>
@@ -11457,7 +11457,7 @@
                             <a:srgbClr val="E2E8F0"/>
                           </a:solidFill>
                         </a:rPr>
-                        <a:t>Fri 07 Aug 2026  11:00 AM</a:t>
+                        <a:t>Wed 16 Sep 2026  11:00 AM</a:t>
                       </a:r>
                     </a:p>
                   </a:txBody>
@@ -11499,7 +11499,7 @@
                             <a:srgbClr val="E2E8F0"/>
                           </a:solidFill>
                         </a:rPr>
-                        <a:t>Fri 07 Aug 2026  09:00 AM</a:t>
+                        <a:t>Wed 16 Sep 2026  09:00 AM</a:t>
                       </a:r>
                     </a:p>
                   </a:txBody>
@@ -11541,7 +11541,7 @@
                             <a:srgbClr val="E2E8F0"/>
                           </a:solidFill>
                         </a:rPr>
-                        <a:t>Fri 07 Aug 2026  07:00 AM</a:t>
+                        <a:t>Wed 16 Sep 2026  07:00 AM</a:t>
                       </a:r>
                     </a:p>
                   </a:txBody>
@@ -11583,7 +11583,7 @@
                             <a:srgbClr val="E2E8F0"/>
                           </a:solidFill>
                         </a:rPr>
-                        <a:t>https://events.sumologic.com/bp4qepm08062026-event-training</a:t>
+                        <a:t>https://events.sumologic.com/administrationpm09152026-event-training</a:t>
                       </a:r>
                     </a:p>
                   </a:txBody>
@@ -11627,7 +11627,7 @@
                             <a:srgbClr val="E2E8F0"/>
                           </a:solidFill>
                         </a:rPr>
-                        <a:t>Administration AM</a:t>
+                        <a:t>Logs for Security AM</a:t>
                       </a:r>
                     </a:p>
                   </a:txBody>
@@ -11669,7 +11669,7 @@
                             <a:srgbClr val="E2E8F0"/>
                           </a:solidFill>
                         </a:rPr>
-                        <a:t>Tue 11 Aug 2026  07:00 AM  →  10:00 AM</a:t>
+                        <a:t>Wed 16 Sep 2026  07:00 AM  →  10:00 AM</a:t>
                       </a:r>
                     </a:p>
                   </a:txBody>
@@ -11711,7 +11711,7 @@
                             <a:srgbClr val="E2E8F0"/>
                           </a:solidFill>
                         </a:rPr>
-                        <a:t>Wed 12 Aug 2026  02:00 AM</a:t>
+                        <a:t>Thu 17 Sep 2026  02:00 AM</a:t>
                       </a:r>
                     </a:p>
                   </a:txBody>
@@ -11753,7 +11753,7 @@
                             <a:srgbClr val="E2E8F0"/>
                           </a:solidFill>
                         </a:rPr>
-                        <a:t>Wed 12 Aug 2026  12:00 AM</a:t>
+                        <a:t>Thu 17 Sep 2026  12:00 AM</a:t>
                       </a:r>
                     </a:p>
                   </a:txBody>
@@ -11795,7 +11795,7 @@
                             <a:srgbClr val="E2E8F0"/>
                           </a:solidFill>
                         </a:rPr>
-                        <a:t>Tue 11 Aug 2026  10:00 PM</a:t>
+                        <a:t>Wed 16 Sep 2026  10:00 PM</a:t>
                       </a:r>
                     </a:p>
                   </a:txBody>
@@ -11837,7 +11837,7 @@
                             <a:srgbClr val="E2E8F0"/>
                           </a:solidFill>
                         </a:rPr>
-                        <a:t>https://events.sumologic.com/administrationam08112026-event-training</a:t>
+                        <a:t>https://events.sumologic.com/logsforsecurityam09162026-event-training</a:t>
                       </a:r>
                     </a:p>
                   </a:txBody>
@@ -11881,7 +11881,7 @@
                             <a:srgbClr val="E2E8F0"/>
                           </a:solidFill>
                         </a:rPr>
-                        <a:t>Administration PM</a:t>
+                        <a:t>Logs for Security PM</a:t>
                       </a:r>
                     </a:p>
                   </a:txBody>
@@ -11923,7 +11923,7 @@
                             <a:srgbClr val="E2E8F0"/>
                           </a:solidFill>
                         </a:rPr>
-                        <a:t>Tue 11 Aug 2026  04:00 PM  →  07:00 PM</a:t>
+                        <a:t>Wed 16 Sep 2026  04:00 PM  →  07:00 PM</a:t>
                       </a:r>
                     </a:p>
                   </a:txBody>
@@ -11965,7 +11965,7 @@
                             <a:srgbClr val="E2E8F0"/>
                           </a:solidFill>
                         </a:rPr>
-                        <a:t>Wed 12 Aug 2026  11:00 AM</a:t>
+                        <a:t>Thu 17 Sep 2026  11:00 AM</a:t>
                       </a:r>
                     </a:p>
                   </a:txBody>
@@ -12007,7 +12007,7 @@
                             <a:srgbClr val="E2E8F0"/>
                           </a:solidFill>
                         </a:rPr>
-                        <a:t>Wed 12 Aug 2026  09:00 AM</a:t>
+                        <a:t>Thu 17 Sep 2026  09:00 AM</a:t>
                       </a:r>
                     </a:p>
                   </a:txBody>
@@ -12049,7 +12049,7 @@
                             <a:srgbClr val="E2E8F0"/>
                           </a:solidFill>
                         </a:rPr>
-                        <a:t>Wed 12 Aug 2026  07:00 AM</a:t>
+                        <a:t>Thu 17 Sep 2026  07:00 AM</a:t>
                       </a:r>
                     </a:p>
                   </a:txBody>
@@ -12091,7 +12091,7 @@
                             <a:srgbClr val="E2E8F0"/>
                           </a:solidFill>
                         </a:rPr>
-                        <a:t>https://events.sumologic.com/administrationpm08112026-event-training</a:t>
+                        <a:t>https://events.sumologic.com/logsforsecuritypm09162026-event-training</a:t>
                       </a:r>
                     </a:p>
                   </a:txBody>
@@ -12291,7 +12291,7 @@
                   <a:srgbClr val="00B4D8"/>
                 </a:solidFill>
               </a:rPr>
-              <a:t>Sumo Logic — Virtual Training Schedule   ·   12 Aug 2026 – 08 Sep 2026   (4/6)</a:t>
+              <a:t>Sumo Logic — Virtual Training Schedule   ·   17 Sep 2026 – 06 Oct 2026   (4/6)</a:t>
             </a:r>
           </a:p>
         </p:txBody>
@@ -12623,7 +12623,7 @@
                             <a:srgbClr val="E2E8F0"/>
                           </a:solidFill>
                         </a:rPr>
-                        <a:t>Metrics Analytics AM</a:t>
+                        <a:t>Hands on with Mobot and Dojo AI AM</a:t>
                       </a:r>
                     </a:p>
                   </a:txBody>
@@ -12665,7 +12665,7 @@
                             <a:srgbClr val="E2E8F0"/>
                           </a:solidFill>
                         </a:rPr>
-                        <a:t>Wed 12 Aug 2026  07:00 AM  →  10:00 AM</a:t>
+                        <a:t>Thu 17 Sep 2026  07:00 AM  →  08:30 AM</a:t>
                       </a:r>
                     </a:p>
                   </a:txBody>
@@ -12707,7 +12707,7 @@
                             <a:srgbClr val="E2E8F0"/>
                           </a:solidFill>
                         </a:rPr>
-                        <a:t>Thu 13 Aug 2026  02:00 AM</a:t>
+                        <a:t>Fri 18 Sep 2026  02:00 AM</a:t>
                       </a:r>
                     </a:p>
                   </a:txBody>
@@ -12749,7 +12749,7 @@
                             <a:srgbClr val="E2E8F0"/>
                           </a:solidFill>
                         </a:rPr>
-                        <a:t>Thu 13 Aug 2026  12:00 AM</a:t>
+                        <a:t>Fri 18 Sep 2026  12:00 AM</a:t>
                       </a:r>
                     </a:p>
                   </a:txBody>
@@ -12791,7 +12791,7 @@
                             <a:srgbClr val="E2E8F0"/>
                           </a:solidFill>
                         </a:rPr>
-                        <a:t>Wed 12 Aug 2026  10:00 PM</a:t>
+                        <a:t>Thu 17 Sep 2026  10:00 PM</a:t>
                       </a:r>
                     </a:p>
                   </a:txBody>
@@ -12833,7 +12833,7 @@
                             <a:srgbClr val="E2E8F0"/>
                           </a:solidFill>
                         </a:rPr>
-                        <a:t>https://events.sumologic.com/metricsanalyticsam08122026-event-training</a:t>
+                        <a:t>https://events.sumologic.com/mobotessentialsam09172026-event-training</a:t>
                       </a:r>
                     </a:p>
                   </a:txBody>
@@ -12877,7 +12877,7 @@
                             <a:srgbClr val="E2E8F0"/>
                           </a:solidFill>
                         </a:rPr>
-                        <a:t>Metrics Analytics PM</a:t>
+                        <a:t>Hands on with Mobot and Dojo AI PM</a:t>
                       </a:r>
                     </a:p>
                   </a:txBody>
@@ -12919,7 +12919,7 @@
                             <a:srgbClr val="E2E8F0"/>
                           </a:solidFill>
                         </a:rPr>
-                        <a:t>Wed 12 Aug 2026  04:00 PM  →  07:00 PM</a:t>
+                        <a:t>Thu 17 Sep 2026  01:00 PM  →  05:25 PM</a:t>
                       </a:r>
                     </a:p>
                   </a:txBody>
@@ -12961,7 +12961,7 @@
                             <a:srgbClr val="E2E8F0"/>
                           </a:solidFill>
                         </a:rPr>
-                        <a:t>Thu 13 Aug 2026  11:00 AM</a:t>
+                        <a:t>Fri 18 Sep 2026  08:00 AM</a:t>
                       </a:r>
                     </a:p>
                   </a:txBody>
@@ -13003,7 +13003,7 @@
                             <a:srgbClr val="E2E8F0"/>
                           </a:solidFill>
                         </a:rPr>
-                        <a:t>Thu 13 Aug 2026  09:00 AM</a:t>
+                        <a:t>Fri 18 Sep 2026  06:00 AM</a:t>
                       </a:r>
                     </a:p>
                   </a:txBody>
@@ -13045,7 +13045,7 @@
                             <a:srgbClr val="E2E8F0"/>
                           </a:solidFill>
                         </a:rPr>
-                        <a:t>Thu 13 Aug 2026  07:00 AM</a:t>
+                        <a:t>Fri 18 Sep 2026  04:00 AM</a:t>
                       </a:r>
                     </a:p>
                   </a:txBody>
@@ -13087,7 +13087,7 @@
                             <a:srgbClr val="E2E8F0"/>
                           </a:solidFill>
                         </a:rPr>
-                        <a:t>https://events.sumologic.com/metricsanalyticspm08122026-event-training</a:t>
+                        <a:t>https://events.sumologic.com/mobotessentialspm09172026-event-training</a:t>
                       </a:r>
                     </a:p>
                   </a:txBody>
@@ -13131,7 +13131,7 @@
                             <a:srgbClr val="E2E8F0"/>
                           </a:solidFill>
                         </a:rPr>
-                        <a:t>Mobot Essentials AM</a:t>
+                        <a:t>Essential SIEM Skills for SOC Analysts AM</a:t>
                       </a:r>
                     </a:p>
                   </a:txBody>
@@ -13173,7 +13173,7 @@
                             <a:srgbClr val="E2E8F0"/>
                           </a:solidFill>
                         </a:rPr>
-                        <a:t>Thu 13 Aug 2026  07:00 AM  →  08:30 AM</a:t>
+                        <a:t>Tue 22 Sep 2026  07:00 AM  →  08:30 AM</a:t>
                       </a:r>
                     </a:p>
                   </a:txBody>
@@ -13215,7 +13215,7 @@
                             <a:srgbClr val="E2E8F0"/>
                           </a:solidFill>
                         </a:rPr>
-                        <a:t>Fri 14 Aug 2026  02:00 AM</a:t>
+                        <a:t>Wed 23 Sep 2026  02:00 AM</a:t>
                       </a:r>
                     </a:p>
                   </a:txBody>
@@ -13257,7 +13257,7 @@
                             <a:srgbClr val="E2E8F0"/>
                           </a:solidFill>
                         </a:rPr>
-                        <a:t>Fri 14 Aug 2026  12:00 AM</a:t>
+                        <a:t>Wed 23 Sep 2026  12:00 AM</a:t>
                       </a:r>
                     </a:p>
                   </a:txBody>
@@ -13299,7 +13299,7 @@
                             <a:srgbClr val="E2E8F0"/>
                           </a:solidFill>
                         </a:rPr>
-                        <a:t>Thu 13 Aug 2026  10:00 PM</a:t>
+                        <a:t>Tue 22 Sep 2026  10:00 PM</a:t>
                       </a:r>
                     </a:p>
                   </a:txBody>
@@ -13341,7 +13341,7 @@
                             <a:srgbClr val="E2E8F0"/>
                           </a:solidFill>
                         </a:rPr>
-                        <a:t>https://events.sumologic.com/mobotessentialsam08132026-event-training</a:t>
+                        <a:t>https://events.sumologic.com/esssiemam09222026-event-training</a:t>
                       </a:r>
                     </a:p>
                   </a:txBody>
@@ -13385,7 +13385,7 @@
                             <a:srgbClr val="E2E8F0"/>
                           </a:solidFill>
                         </a:rPr>
-                        <a:t>Mobot Essentials PM</a:t>
+                        <a:t>Essential SIEM Skills for SOC Analysts PM</a:t>
                       </a:r>
                     </a:p>
                   </a:txBody>
@@ -13427,7 +13427,7 @@
                             <a:srgbClr val="E2E8F0"/>
                           </a:solidFill>
                         </a:rPr>
-                        <a:t>Thu 13 Aug 2026  04:00 PM  →  05:30 PM</a:t>
+                        <a:t>Tue 22 Sep 2026  04:00 PM  →  05:30 PM</a:t>
                       </a:r>
                     </a:p>
                   </a:txBody>
@@ -13469,7 +13469,7 @@
                             <a:srgbClr val="E2E8F0"/>
                           </a:solidFill>
                         </a:rPr>
-                        <a:t>Fri 14 Aug 2026  11:00 AM</a:t>
+                        <a:t>Wed 23 Sep 2026  11:00 AM</a:t>
                       </a:r>
                     </a:p>
                   </a:txBody>
@@ -13511,7 +13511,7 @@
                             <a:srgbClr val="E2E8F0"/>
                           </a:solidFill>
                         </a:rPr>
-                        <a:t>Fri 14 Aug 2026  09:00 AM</a:t>
+                        <a:t>Wed 23 Sep 2026  09:00 AM</a:t>
                       </a:r>
                     </a:p>
                   </a:txBody>
@@ -13553,7 +13553,7 @@
                             <a:srgbClr val="E2E8F0"/>
                           </a:solidFill>
                         </a:rPr>
-                        <a:t>Fri 14 Aug 2026  07:00 AM</a:t>
+                        <a:t>Wed 23 Sep 2026  07:00 AM</a:t>
                       </a:r>
                     </a:p>
                   </a:txBody>
@@ -13595,7 +13595,7 @@
                             <a:srgbClr val="E2E8F0"/>
                           </a:solidFill>
                         </a:rPr>
-                        <a:t>https://events.sumologic.com/mobotessentialspm08132026-event-training</a:t>
+                        <a:t>https://events.sumologic.com/esssiempm09222026-event-training</a:t>
                       </a:r>
                     </a:p>
                   </a:txBody>
@@ -13639,7 +13639,7 @@
                             <a:srgbClr val="E2E8F0"/>
                           </a:solidFill>
                         </a:rPr>
-                        <a:t>Essential Cloud SIEM Skills for SOC Analysts AM</a:t>
+                        <a:t>Cloud SIEM AM</a:t>
                       </a:r>
                     </a:p>
                   </a:txBody>
@@ -13681,7 +13681,7 @@
                             <a:srgbClr val="E2E8F0"/>
                           </a:solidFill>
                         </a:rPr>
-                        <a:t>Tue 18 Aug 2026  07:00 AM  →  08:30 AM</a:t>
+                        <a:t>Wed 23 Sep 2026  07:00 AM  →  10:00 AM</a:t>
                       </a:r>
                     </a:p>
                   </a:txBody>
@@ -13723,7 +13723,7 @@
                             <a:srgbClr val="E2E8F0"/>
                           </a:solidFill>
                         </a:rPr>
-                        <a:t>Wed 19 Aug 2026  02:00 AM</a:t>
+                        <a:t>Thu 24 Sep 2026  02:00 AM</a:t>
                       </a:r>
                     </a:p>
                   </a:txBody>
@@ -13765,7 +13765,7 @@
                             <a:srgbClr val="E2E8F0"/>
                           </a:solidFill>
                         </a:rPr>
-                        <a:t>Wed 19 Aug 2026  12:00 AM</a:t>
+                        <a:t>Thu 24 Sep 2026  12:00 AM</a:t>
                       </a:r>
                     </a:p>
                   </a:txBody>
@@ -13807,7 +13807,7 @@
                             <a:srgbClr val="E2E8F0"/>
                           </a:solidFill>
                         </a:rPr>
-                        <a:t>Tue 18 Aug 2026  10:00 PM</a:t>
+                        <a:t>Wed 23 Sep 2026  10:00 PM</a:t>
                       </a:r>
                     </a:p>
                   </a:txBody>
@@ -13849,7 +13849,7 @@
                             <a:srgbClr val="E2E8F0"/>
                           </a:solidFill>
                         </a:rPr>
-                        <a:t>https://events.sumologic.com/esscloudsiemam08182026-event-training</a:t>
+                        <a:t>https://events.sumologic.com/cloudsiemam09232026-event-training</a:t>
                       </a:r>
                     </a:p>
                   </a:txBody>
@@ -13893,7 +13893,7 @@
                             <a:srgbClr val="E2E8F0"/>
                           </a:solidFill>
                         </a:rPr>
-                        <a:t>Essential Cloud SIEM Skills for SOC Analysts PM</a:t>
+                        <a:t>Cloud SIEM PM</a:t>
                       </a:r>
                     </a:p>
                   </a:txBody>
@@ -13935,7 +13935,7 @@
                             <a:srgbClr val="E2E8F0"/>
                           </a:solidFill>
                         </a:rPr>
-                        <a:t>Tue 18 Aug 2026  04:00 PM  →  05:30 PM</a:t>
+                        <a:t>Wed 23 Sep 2026  04:00 PM  →  07:00 PM</a:t>
                       </a:r>
                     </a:p>
                   </a:txBody>
@@ -13977,7 +13977,7 @@
                             <a:srgbClr val="E2E8F0"/>
                           </a:solidFill>
                         </a:rPr>
-                        <a:t>Wed 19 Aug 2026  11:00 AM</a:t>
+                        <a:t>Thu 24 Sep 2026  11:00 AM</a:t>
                       </a:r>
                     </a:p>
                   </a:txBody>
@@ -14019,7 +14019,7 @@
                             <a:srgbClr val="E2E8F0"/>
                           </a:solidFill>
                         </a:rPr>
-                        <a:t>Wed 19 Aug 2026  09:00 AM</a:t>
+                        <a:t>Thu 24 Sep 2026  09:00 AM</a:t>
                       </a:r>
                     </a:p>
                   </a:txBody>
@@ -14061,7 +14061,7 @@
                             <a:srgbClr val="E2E8F0"/>
                           </a:solidFill>
                         </a:rPr>
-                        <a:t>Wed 19 Aug 2026  07:00 AM</a:t>
+                        <a:t>Thu 24 Sep 2026  07:00 AM</a:t>
                       </a:r>
                     </a:p>
                   </a:txBody>
@@ -14103,7 +14103,7 @@
                             <a:srgbClr val="E2E8F0"/>
                           </a:solidFill>
                         </a:rPr>
-                        <a:t>https://events.sumologic.com/esscloudsiempm08182026-event-training</a:t>
+                        <a:t>https://events.sumologic.com/cloudsiempm09232026-event-training</a:t>
                       </a:r>
                     </a:p>
                   </a:txBody>
@@ -14147,7 +14147,7 @@
                             <a:srgbClr val="E2E8F0"/>
                           </a:solidFill>
                         </a:rPr>
-                        <a:t>Cloud SIEM AM</a:t>
+                        <a:t>Automation AM</a:t>
                       </a:r>
                     </a:p>
                   </a:txBody>
@@ -14189,7 +14189,7 @@
                             <a:srgbClr val="E2E8F0"/>
                           </a:solidFill>
                         </a:rPr>
-                        <a:t>Wed 19 Aug 2026  07:00 AM  →  10:00 AM</a:t>
+                        <a:t>Thu 24 Sep 2026  07:00 AM  →  08:30 AM</a:t>
                       </a:r>
                     </a:p>
                   </a:txBody>
@@ -14231,7 +14231,7 @@
                             <a:srgbClr val="E2E8F0"/>
                           </a:solidFill>
                         </a:rPr>
-                        <a:t>Thu 20 Aug 2026  02:00 AM</a:t>
+                        <a:t>Fri 25 Sep 2026  02:00 AM</a:t>
                       </a:r>
                     </a:p>
                   </a:txBody>
@@ -14273,7 +14273,7 @@
                             <a:srgbClr val="E2E8F0"/>
                           </a:solidFill>
                         </a:rPr>
-                        <a:t>Thu 20 Aug 2026  12:00 AM</a:t>
+                        <a:t>Fri 25 Sep 2026  12:00 AM</a:t>
                       </a:r>
                     </a:p>
                   </a:txBody>
@@ -14315,7 +14315,7 @@
                             <a:srgbClr val="E2E8F0"/>
                           </a:solidFill>
                         </a:rPr>
-                        <a:t>Wed 19 Aug 2026  10:00 PM</a:t>
+                        <a:t>Thu 24 Sep 2026  10:00 PM</a:t>
                       </a:r>
                     </a:p>
                   </a:txBody>
@@ -14357,7 +14357,7 @@
                             <a:srgbClr val="E2E8F0"/>
                           </a:solidFill>
                         </a:rPr>
-                        <a:t>https://events.sumologic.com/cloudsiemam08192026-event-training</a:t>
+                        <a:t>https://events.sumologic.com/automationam09242026-event-training</a:t>
                       </a:r>
                     </a:p>
                   </a:txBody>
@@ -14401,7 +14401,7 @@
                             <a:srgbClr val="E2E8F0"/>
                           </a:solidFill>
                         </a:rPr>
-                        <a:t>Cloud SIEM PM</a:t>
+                        <a:t>Automation PM</a:t>
                       </a:r>
                     </a:p>
                   </a:txBody>
@@ -14443,7 +14443,7 @@
                             <a:srgbClr val="E2E8F0"/>
                           </a:solidFill>
                         </a:rPr>
-                        <a:t>Wed 19 Aug 2026  04:00 PM  →  07:00 PM</a:t>
+                        <a:t>Thu 24 Sep 2026  04:00 PM  →  05:30 PM</a:t>
                       </a:r>
                     </a:p>
                   </a:txBody>
@@ -14485,7 +14485,7 @@
                             <a:srgbClr val="E2E8F0"/>
                           </a:solidFill>
                         </a:rPr>
-                        <a:t>Thu 20 Aug 2026  11:00 AM</a:t>
+                        <a:t>Fri 25 Sep 2026  11:00 AM</a:t>
                       </a:r>
                     </a:p>
                   </a:txBody>
@@ -14527,7 +14527,7 @@
                             <a:srgbClr val="E2E8F0"/>
                           </a:solidFill>
                         </a:rPr>
-                        <a:t>Thu 20 Aug 2026  09:00 AM</a:t>
+                        <a:t>Fri 25 Sep 2026  09:00 AM</a:t>
                       </a:r>
                     </a:p>
                   </a:txBody>
@@ -14569,7 +14569,7 @@
                             <a:srgbClr val="E2E8F0"/>
                           </a:solidFill>
                         </a:rPr>
-                        <a:t>Thu 20 Aug 2026  07:00 AM</a:t>
+                        <a:t>Fri 25 Sep 2026  07:00 AM</a:t>
                       </a:r>
                     </a:p>
                   </a:txBody>
@@ -14611,7 +14611,7 @@
                             <a:srgbClr val="E2E8F0"/>
                           </a:solidFill>
                         </a:rPr>
-                        <a:t>https://events.sumologic.com/cloudsiempm08192026-event-training</a:t>
+                        <a:t>https://events.sumologic.com/automationpm09242026-event-training</a:t>
                       </a:r>
                     </a:p>
                   </a:txBody>
@@ -14697,7 +14697,7 @@
                             <a:srgbClr val="E2E8F0"/>
                           </a:solidFill>
                         </a:rPr>
-                        <a:t>Tue 08 Sep 2026  05:00 AM  →  06:00 AM</a:t>
+                        <a:t>Tue 06 Oct 2026  05:00 AM  →  06:00 AM</a:t>
                       </a:r>
                     </a:p>
                   </a:txBody>
@@ -14739,7 +14739,7 @@
                             <a:srgbClr val="E2E8F0"/>
                           </a:solidFill>
                         </a:rPr>
-                        <a:t>Wed 09 Sep 2026  12:00 AM</a:t>
+                        <a:t>Wed 07 Oct 2026  01:00 AM</a:t>
                       </a:r>
                     </a:p>
                   </a:txBody>
@@ -14781,7 +14781,7 @@
                             <a:srgbClr val="E2E8F0"/>
                           </a:solidFill>
                         </a:rPr>
-                        <a:t>Tue 08 Sep 2026  10:00 PM</a:t>
+                        <a:t>Tue 06 Oct 2026  11:00 PM</a:t>
                       </a:r>
                     </a:p>
                   </a:txBody>
@@ -14823,7 +14823,7 @@
                             <a:srgbClr val="E2E8F0"/>
                           </a:solidFill>
                         </a:rPr>
-                        <a:t>Tue 08 Sep 2026  08:00 PM</a:t>
+                        <a:t>Tue 06 Oct 2026  08:00 PM</a:t>
                       </a:r>
                     </a:p>
                   </a:txBody>
@@ -14865,7 +14865,7 @@
                             <a:srgbClr val="E2E8F0"/>
                           </a:solidFill>
                         </a:rPr>
-                        <a:t>https://events.sumologic.com/welcomewebinaram09082026-event-training</a:t>
+                        <a:t>https://events.sumologic.com/welcomewebinaram10062026-event-training</a:t>
                       </a:r>
                     </a:p>
                   </a:txBody>
@@ -14951,7 +14951,7 @@
                             <a:srgbClr val="E2E8F0"/>
                           </a:solidFill>
                         </a:rPr>
-                        <a:t>Tue 08 Sep 2026  07:00 AM  →  10:00 AM</a:t>
+                        <a:t>Tue 06 Oct 2026  07:00 AM  →  10:00 AM</a:t>
                       </a:r>
                     </a:p>
                   </a:txBody>
@@ -14993,7 +14993,7 @@
                             <a:srgbClr val="E2E8F0"/>
                           </a:solidFill>
                         </a:rPr>
-                        <a:t>Wed 09 Sep 2026  02:00 AM</a:t>
+                        <a:t>Wed 07 Oct 2026  03:00 AM</a:t>
                       </a:r>
                     </a:p>
                   </a:txBody>
@@ -15035,7 +15035,7 @@
                             <a:srgbClr val="E2E8F0"/>
                           </a:solidFill>
                         </a:rPr>
-                        <a:t>Wed 09 Sep 2026  12:00 AM</a:t>
+                        <a:t>Wed 07 Oct 2026  01:00 AM</a:t>
                       </a:r>
                     </a:p>
                   </a:txBody>
@@ -15077,7 +15077,7 @@
                             <a:srgbClr val="E2E8F0"/>
                           </a:solidFill>
                         </a:rPr>
-                        <a:t>Tue 08 Sep 2026  10:00 PM</a:t>
+                        <a:t>Tue 06 Oct 2026  10:00 PM</a:t>
                       </a:r>
                     </a:p>
                   </a:txBody>
@@ -15119,7 +15119,7 @@
                             <a:srgbClr val="E2E8F0"/>
                           </a:solidFill>
                         </a:rPr>
-                        <a:t>https://events.sumologic.com/fundamentalsam09082026-event-training</a:t>
+                        <a:t>https://events.sumologic.com/fundamentalsam10062026-event-training</a:t>
                       </a:r>
                     </a:p>
                   </a:txBody>
@@ -15319,7 +15319,7 @@
                   <a:srgbClr val="00B4D8"/>
                 </a:solidFill>
               </a:rPr>
-              <a:t>Sumo Logic — Virtual Training Schedule   ·   08 Sep – 16 Sep 2026   (5/6)</a:t>
+              <a:t>Sumo Logic — Virtual Training Schedule   ·   06 Oct – 14 Oct 2026   (5/6)</a:t>
             </a:r>
           </a:p>
         </p:txBody>
@@ -15693,7 +15693,7 @@
                             <a:srgbClr val="E2E8F0"/>
                           </a:solidFill>
                         </a:rPr>
-                        <a:t>Tue 08 Sep 2026  02:00 PM  →  03:00 PM</a:t>
+                        <a:t>Tue 06 Oct 2026  02:00 PM  →  03:00 PM</a:t>
                       </a:r>
                     </a:p>
                   </a:txBody>
@@ -15735,7 +15735,7 @@
                             <a:srgbClr val="E2E8F0"/>
                           </a:solidFill>
                         </a:rPr>
-                        <a:t>Wed 09 Sep 2026  09:00 AM</a:t>
+                        <a:t>Wed 07 Oct 2026  10:00 AM</a:t>
                       </a:r>
                     </a:p>
                   </a:txBody>
@@ -15777,7 +15777,7 @@
                             <a:srgbClr val="E2E8F0"/>
                           </a:solidFill>
                         </a:rPr>
-                        <a:t>Wed 09 Sep 2026  07:00 AM</a:t>
+                        <a:t>Wed 07 Oct 2026  08:00 AM</a:t>
                       </a:r>
                     </a:p>
                   </a:txBody>
@@ -15819,7 +15819,7 @@
                             <a:srgbClr val="E2E8F0"/>
                           </a:solidFill>
                         </a:rPr>
-                        <a:t>Wed 09 Sep 2026  05:00 AM</a:t>
+                        <a:t>Wed 07 Oct 2026  05:00 AM</a:t>
                       </a:r>
                     </a:p>
                   </a:txBody>
@@ -15861,7 +15861,7 @@
                             <a:srgbClr val="E2E8F0"/>
                           </a:solidFill>
                         </a:rPr>
-                        <a:t>https://events.sumologic.com/welcomewebinarpm09082026-event-training</a:t>
+                        <a:t>https://events.sumologic.com/welcomewebinarpm10062026-event-training</a:t>
                       </a:r>
                     </a:p>
                   </a:txBody>
@@ -15947,7 +15947,7 @@
                             <a:srgbClr val="E2E8F0"/>
                           </a:solidFill>
                         </a:rPr>
-                        <a:t>Tue 08 Sep 2026  04:00 PM  →  07:00 PM</a:t>
+                        <a:t>Tue 06 Oct 2026  04:00 PM  →  07:00 PM</a:t>
                       </a:r>
                     </a:p>
                   </a:txBody>
@@ -15989,7 +15989,7 @@
                             <a:srgbClr val="E2E8F0"/>
                           </a:solidFill>
                         </a:rPr>
-                        <a:t>Wed 09 Sep 2026  11:00 AM</a:t>
+                        <a:t>Wed 07 Oct 2026  12:00 PM</a:t>
                       </a:r>
                     </a:p>
                   </a:txBody>
@@ -16031,7 +16031,7 @@
                             <a:srgbClr val="E2E8F0"/>
                           </a:solidFill>
                         </a:rPr>
-                        <a:t>Wed 09 Sep 2026  09:00 AM</a:t>
+                        <a:t>Wed 07 Oct 2026  10:00 AM</a:t>
                       </a:r>
                     </a:p>
                   </a:txBody>
@@ -16073,7 +16073,7 @@
                             <a:srgbClr val="E2E8F0"/>
                           </a:solidFill>
                         </a:rPr>
-                        <a:t>Wed 09 Sep 2026  07:00 AM</a:t>
+                        <a:t>Wed 07 Oct 2026  07:00 AM</a:t>
                       </a:r>
                     </a:p>
                   </a:txBody>
@@ -16115,7 +16115,7 @@
                             <a:srgbClr val="E2E8F0"/>
                           </a:solidFill>
                         </a:rPr>
-                        <a:t>https://events.sumologic.com/fundamentalspm09082026-event-training</a:t>
+                        <a:t>https://events.sumologic.com/fundamentalspm10062026-event-training</a:t>
                       </a:r>
                     </a:p>
                   </a:txBody>
@@ -16201,7 +16201,7 @@
                             <a:srgbClr val="E2E8F0"/>
                           </a:solidFill>
                         </a:rPr>
-                        <a:t>Wed 09 Sep 2026  07:00 AM  →  10:00 AM</a:t>
+                        <a:t>Wed 07 Oct 2026  07:00 AM  →  10:00 AM</a:t>
                       </a:r>
                     </a:p>
                   </a:txBody>
@@ -16243,7 +16243,7 @@
                             <a:srgbClr val="E2E8F0"/>
                           </a:solidFill>
                         </a:rPr>
-                        <a:t>Thu 10 Sep 2026  02:00 AM</a:t>
+                        <a:t>Thu 08 Oct 2026  03:00 AM</a:t>
                       </a:r>
                     </a:p>
                   </a:txBody>
@@ -16285,7 +16285,7 @@
                             <a:srgbClr val="E2E8F0"/>
                           </a:solidFill>
                         </a:rPr>
-                        <a:t>Thu 10 Sep 2026  12:00 AM</a:t>
+                        <a:t>Thu 08 Oct 2026  01:00 AM</a:t>
                       </a:r>
                     </a:p>
                   </a:txBody>
@@ -16327,7 +16327,7 @@
                             <a:srgbClr val="E2E8F0"/>
                           </a:solidFill>
                         </a:rPr>
-                        <a:t>Wed 09 Sep 2026  10:00 PM</a:t>
+                        <a:t>Wed 07 Oct 2026  10:00 PM</a:t>
                       </a:r>
                     </a:p>
                   </a:txBody>
@@ -16369,7 +16369,7 @@
                             <a:srgbClr val="E2E8F0"/>
                           </a:solidFill>
                         </a:rPr>
-                        <a:t>https://events.sumologic.com/searchmasteryam09092026-event-training</a:t>
+                        <a:t>https://events.sumologic.com/searchmasteryam10072026-event-training</a:t>
                       </a:r>
                     </a:p>
                   </a:txBody>
@@ -16455,7 +16455,7 @@
                             <a:srgbClr val="E2E8F0"/>
                           </a:solidFill>
                         </a:rPr>
-                        <a:t>Wed 09 Sep 2026  04:00 PM  →  07:00 PM</a:t>
+                        <a:t>Wed 07 Oct 2026  04:00 PM  →  07:00 PM</a:t>
                       </a:r>
                     </a:p>
                   </a:txBody>
@@ -16497,7 +16497,7 @@
                             <a:srgbClr val="E2E8F0"/>
                           </a:solidFill>
                         </a:rPr>
-                        <a:t>Thu 10 Sep 2026  11:00 AM</a:t>
+                        <a:t>Thu 08 Oct 2026  12:00 PM</a:t>
                       </a:r>
                     </a:p>
                   </a:txBody>
@@ -16539,7 +16539,7 @@
                             <a:srgbClr val="E2E8F0"/>
                           </a:solidFill>
                         </a:rPr>
-                        <a:t>Thu 10 Sep 2026  09:00 AM</a:t>
+                        <a:t>Thu 08 Oct 2026  10:00 AM</a:t>
                       </a:r>
                     </a:p>
                   </a:txBody>
@@ -16581,7 +16581,7 @@
                             <a:srgbClr val="E2E8F0"/>
                           </a:solidFill>
                         </a:rPr>
-                        <a:t>Thu 10 Sep 2026  07:00 AM</a:t>
+                        <a:t>Thu 08 Oct 2026  07:00 AM</a:t>
                       </a:r>
                     </a:p>
                   </a:txBody>
@@ -16623,7 +16623,7 @@
                             <a:srgbClr val="E2E8F0"/>
                           </a:solidFill>
                         </a:rPr>
-                        <a:t>https://events.sumologic.com/searchmasterypm09092026-event-training</a:t>
+                        <a:t>https://events.sumologic.com/searchmasterypm10072026-event-training</a:t>
                       </a:r>
                     </a:p>
                   </a:txBody>
@@ -16667,7 +16667,7 @@
                             <a:srgbClr val="E2E8F0"/>
                           </a:solidFill>
                         </a:rPr>
-                        <a:t>Best Practices for Query Efficiency AM</a:t>
+                        <a:t>Best Practice for Query Efficiency  AM</a:t>
                       </a:r>
                     </a:p>
                   </a:txBody>
@@ -16709,7 +16709,7 @@
                             <a:srgbClr val="E2E8F0"/>
                           </a:solidFill>
                         </a:rPr>
-                        <a:t>Thu 10 Sep 2026  07:00 AM  →  08:30 AM</a:t>
+                        <a:t>Thu 08 Oct 2026  07:00 AM  →  08:30 AM</a:t>
                       </a:r>
                     </a:p>
                   </a:txBody>
@@ -16751,7 +16751,7 @@
                             <a:srgbClr val="E2E8F0"/>
                           </a:solidFill>
                         </a:rPr>
-                        <a:t>Fri 11 Sep 2026  02:00 AM</a:t>
+                        <a:t>Fri 09 Oct 2026  03:00 AM</a:t>
                       </a:r>
                     </a:p>
                   </a:txBody>
@@ -16793,7 +16793,7 @@
                             <a:srgbClr val="E2E8F0"/>
                           </a:solidFill>
                         </a:rPr>
-                        <a:t>Fri 11 Sep 2026  12:00 AM</a:t>
+                        <a:t>Fri 09 Oct 2026  01:00 AM</a:t>
                       </a:r>
                     </a:p>
                   </a:txBody>
@@ -16835,7 +16835,7 @@
                             <a:srgbClr val="E2E8F0"/>
                           </a:solidFill>
                         </a:rPr>
-                        <a:t>Thu 10 Sep 2026  10:00 PM</a:t>
+                        <a:t>Thu 08 Oct 2026  10:00 PM</a:t>
                       </a:r>
                     </a:p>
                   </a:txBody>
@@ -16877,7 +16877,7 @@
                             <a:srgbClr val="E2E8F0"/>
                           </a:solidFill>
                         </a:rPr>
-                        <a:t>https://events.sumologic.com/bp4qeam09102026-event-training</a:t>
+                        <a:t/>
                       </a:r>
                     </a:p>
                   </a:txBody>
@@ -16921,7 +16921,7 @@
                             <a:srgbClr val="E2E8F0"/>
                           </a:solidFill>
                         </a:rPr>
-                        <a:t>Best Practices for Query Efficiency PM</a:t>
+                        <a:t>Best Practice for Query Efficiency PM</a:t>
                       </a:r>
                     </a:p>
                   </a:txBody>
@@ -16963,7 +16963,7 @@
                             <a:srgbClr val="E2E8F0"/>
                           </a:solidFill>
                         </a:rPr>
-                        <a:t>Thu 10 Sep 2026  04:00 PM  →  05:30 PM</a:t>
+                        <a:t>Thu 08 Oct 2026  04:00 PM  →  05:30 PM</a:t>
                       </a:r>
                     </a:p>
                   </a:txBody>
@@ -17005,7 +17005,7 @@
                             <a:srgbClr val="E2E8F0"/>
                           </a:solidFill>
                         </a:rPr>
-                        <a:t>Fri 11 Sep 2026  11:00 AM</a:t>
+                        <a:t>Fri 09 Oct 2026  12:00 PM</a:t>
                       </a:r>
                     </a:p>
                   </a:txBody>
@@ -17047,7 +17047,7 @@
                             <a:srgbClr val="E2E8F0"/>
                           </a:solidFill>
                         </a:rPr>
-                        <a:t>Fri 11 Sep 2026  09:00 AM</a:t>
+                        <a:t>Fri 09 Oct 2026  10:00 AM</a:t>
                       </a:r>
                     </a:p>
                   </a:txBody>
@@ -17089,7 +17089,7 @@
                             <a:srgbClr val="E2E8F0"/>
                           </a:solidFill>
                         </a:rPr>
-                        <a:t>Fri 11 Sep 2026  07:00 AM</a:t>
+                        <a:t>Fri 09 Oct 2026  07:00 AM</a:t>
                       </a:r>
                     </a:p>
                   </a:txBody>
@@ -17131,7 +17131,7 @@
                             <a:srgbClr val="E2E8F0"/>
                           </a:solidFill>
                         </a:rPr>
-                        <a:t>https://events.sumologic.com/bp4qepm09102026-event-training</a:t>
+                        <a:t>https://events.sumologic.com/bp4qepm10082026-event-training</a:t>
                       </a:r>
                     </a:p>
                   </a:txBody>
@@ -17217,7 +17217,7 @@
                             <a:srgbClr val="E2E8F0"/>
                           </a:solidFill>
                         </a:rPr>
-                        <a:t>Tue 15 Sep 2026  07:00 AM  →  10:00 AM</a:t>
+                        <a:t>Tue 13 Oct 2026  07:00 AM  →  10:00 AM</a:t>
                       </a:r>
                     </a:p>
                   </a:txBody>
@@ -17259,7 +17259,7 @@
                             <a:srgbClr val="E2E8F0"/>
                           </a:solidFill>
                         </a:rPr>
-                        <a:t>Wed 16 Sep 2026  02:00 AM</a:t>
+                        <a:t>Wed 14 Oct 2026  03:00 AM</a:t>
                       </a:r>
                     </a:p>
                   </a:txBody>
@@ -17301,7 +17301,7 @@
                             <a:srgbClr val="E2E8F0"/>
                           </a:solidFill>
                         </a:rPr>
-                        <a:t>Wed 16 Sep 2026  12:00 AM</a:t>
+                        <a:t>Wed 14 Oct 2026  01:00 AM</a:t>
                       </a:r>
                     </a:p>
                   </a:txBody>
@@ -17343,7 +17343,7 @@
                             <a:srgbClr val="E2E8F0"/>
                           </a:solidFill>
                         </a:rPr>
-                        <a:t>Tue 15 Sep 2026  10:00 PM</a:t>
+                        <a:t>Tue 13 Oct 2026  10:00 PM</a:t>
                       </a:r>
                     </a:p>
                   </a:txBody>
@@ -17385,7 +17385,7 @@
                             <a:srgbClr val="E2E8F0"/>
                           </a:solidFill>
                         </a:rPr>
-                        <a:t>https://events.sumologic.com/administrationam09152026-event-training</a:t>
+                        <a:t>https://events.sumologic.com/administrationam10132026-event-training</a:t>
                       </a:r>
                     </a:p>
                   </a:txBody>
@@ -17471,7 +17471,7 @@
                             <a:srgbClr val="E2E8F0"/>
                           </a:solidFill>
                         </a:rPr>
-                        <a:t>Tue 15 Sep 2026  04:00 PM  →  07:00 PM</a:t>
+                        <a:t>Tue 13 Oct 2026  04:00 PM  →  07:00 PM</a:t>
                       </a:r>
                     </a:p>
                   </a:txBody>
@@ -17513,7 +17513,7 @@
                             <a:srgbClr val="E2E8F0"/>
                           </a:solidFill>
                         </a:rPr>
-                        <a:t>Wed 16 Sep 2026  11:00 AM</a:t>
+                        <a:t>Wed 14 Oct 2026  12:00 PM</a:t>
                       </a:r>
                     </a:p>
                   </a:txBody>
@@ -17555,7 +17555,7 @@
                             <a:srgbClr val="E2E8F0"/>
                           </a:solidFill>
                         </a:rPr>
-                        <a:t>Wed 16 Sep 2026  09:00 AM</a:t>
+                        <a:t>Wed 14 Oct 2026  10:00 AM</a:t>
                       </a:r>
                     </a:p>
                   </a:txBody>
@@ -17597,7 +17597,7 @@
                             <a:srgbClr val="E2E8F0"/>
                           </a:solidFill>
                         </a:rPr>
-                        <a:t>Wed 16 Sep 2026  07:00 AM</a:t>
+                        <a:t>Wed 14 Oct 2026  07:00 AM</a:t>
                       </a:r>
                     </a:p>
                   </a:txBody>
@@ -17639,7 +17639,7 @@
                             <a:srgbClr val="E2E8F0"/>
                           </a:solidFill>
                         </a:rPr>
-                        <a:t>https://events.sumologic.com/administrationpm09152026-event-training</a:t>
+                        <a:t>https://events.sumologic.com/administrationpm10132026-event-training</a:t>
                       </a:r>
                     </a:p>
                   </a:txBody>
@@ -17683,7 +17683,7 @@
                             <a:srgbClr val="E2E8F0"/>
                           </a:solidFill>
                         </a:rPr>
-                        <a:t>Logs for Security AM</a:t>
+                        <a:t>Metrics Analytics AM</a:t>
                       </a:r>
                     </a:p>
                   </a:txBody>
@@ -17725,7 +17725,7 @@
                             <a:srgbClr val="E2E8F0"/>
                           </a:solidFill>
                         </a:rPr>
-                        <a:t>Wed 16 Sep 2026  07:00 AM  →  10:00 AM</a:t>
+                        <a:t>Wed 14 Oct 2026  07:00 AM  →  10:00 AM</a:t>
                       </a:r>
                     </a:p>
                   </a:txBody>
@@ -17767,7 +17767,7 @@
                             <a:srgbClr val="E2E8F0"/>
                           </a:solidFill>
                         </a:rPr>
-                        <a:t>Thu 17 Sep 2026  02:00 AM</a:t>
+                        <a:t>Thu 15 Oct 2026  03:00 AM</a:t>
                       </a:r>
                     </a:p>
                   </a:txBody>
@@ -17809,7 +17809,7 @@
                             <a:srgbClr val="E2E8F0"/>
                           </a:solidFill>
                         </a:rPr>
-                        <a:t>Thu 17 Sep 2026  12:00 AM</a:t>
+                        <a:t>Thu 15 Oct 2026  01:00 AM</a:t>
                       </a:r>
                     </a:p>
                   </a:txBody>
@@ -17851,7 +17851,7 @@
                             <a:srgbClr val="E2E8F0"/>
                           </a:solidFill>
                         </a:rPr>
-                        <a:t>Wed 16 Sep 2026  10:00 PM</a:t>
+                        <a:t>Wed 14 Oct 2026  10:00 PM</a:t>
                       </a:r>
                     </a:p>
                   </a:txBody>
@@ -17893,7 +17893,7 @@
                             <a:srgbClr val="E2E8F0"/>
                           </a:solidFill>
                         </a:rPr>
-                        <a:t>https://events.sumologic.com/logsforsecurityam09162026-event-training</a:t>
+                        <a:t>https://events.sumologic.com/metricsanalyticsam10142026-event-training</a:t>
                       </a:r>
                     </a:p>
                   </a:txBody>
@@ -17937,7 +17937,7 @@
                             <a:srgbClr val="E2E8F0"/>
                           </a:solidFill>
                         </a:rPr>
-                        <a:t>Logs for Security PM</a:t>
+                        <a:t>Metrics Analytics PM</a:t>
                       </a:r>
                     </a:p>
                   </a:txBody>
@@ -17979,7 +17979,7 @@
                             <a:srgbClr val="E2E8F0"/>
                           </a:solidFill>
                         </a:rPr>
-                        <a:t>Wed 16 Sep 2026  04:00 PM  →  07:00 PM</a:t>
+                        <a:t>Wed 14 Oct 2026  04:00 PM  →  07:00 PM</a:t>
                       </a:r>
                     </a:p>
                   </a:txBody>
@@ -18021,7 +18021,7 @@
                             <a:srgbClr val="E2E8F0"/>
                           </a:solidFill>
                         </a:rPr>
-                        <a:t>Thu 17 Sep 2026  11:00 AM</a:t>
+                        <a:t>Thu 15 Oct 2026  12:00 PM</a:t>
                       </a:r>
                     </a:p>
                   </a:txBody>
@@ -18063,7 +18063,7 @@
                             <a:srgbClr val="E2E8F0"/>
                           </a:solidFill>
                         </a:rPr>
-                        <a:t>Thu 17 Sep 2026  09:00 AM</a:t>
+                        <a:t>Thu 15 Oct 2026  10:00 AM</a:t>
                       </a:r>
                     </a:p>
                   </a:txBody>
@@ -18105,7 +18105,7 @@
                             <a:srgbClr val="E2E8F0"/>
                           </a:solidFill>
                         </a:rPr>
-                        <a:t>Thu 17 Sep 2026  07:00 AM</a:t>
+                        <a:t>Thu 15 Oct 2026  07:00 AM</a:t>
                       </a:r>
                     </a:p>
                   </a:txBody>
@@ -18147,7 +18147,7 @@
                             <a:srgbClr val="E2E8F0"/>
                           </a:solidFill>
                         </a:rPr>
-                        <a:t>https://events.sumologic.com/logsforsecuritypm09162026-event-training</a:t>
+                        <a:t>https://events.sumologic.com/metricsanalyticspm10142026-event-training</a:t>
                       </a:r>
                     </a:p>
                   </a:txBody>
@@ -18347,7 +18347,7 @@
                   <a:srgbClr val="00B4D8"/>
                 </a:solidFill>
               </a:rPr>
-              <a:t>Sumo Logic — Virtual Training Schedule   ·   17 Sep – 24 Sep 2026   (6/6)</a:t>
+              <a:t>Sumo Logic — Virtual Training Schedule   ·   15 Oct – 22 Oct 2026   (6/6)</a:t>
             </a:r>
           </a:p>
         </p:txBody>
@@ -18396,7 +18396,7 @@
         </p:nvGraphicFramePr>
         <p:xfrm>
           <a:off x="164592" y="640080"/>
-          <a:ext cx="11795760" cy="3675888"/>
+          <a:ext cx="11795760" cy="3255264"/>
         </p:xfrm>
         <a:graphic>
           <a:graphicData uri="http://schemas.openxmlformats.org/drawingml/2006/table">
@@ -18679,7 +18679,7 @@
                             <a:srgbClr val="E2E8F0"/>
                           </a:solidFill>
                         </a:rPr>
-                        <a:t>Mobot Essentials AM</a:t>
+                        <a:t>Hands on with Mobot and Dojo AI AM</a:t>
                       </a:r>
                     </a:p>
                   </a:txBody>
@@ -18721,7 +18721,7 @@
                             <a:srgbClr val="E2E8F0"/>
                           </a:solidFill>
                         </a:rPr>
-                        <a:t>Thu 17 Sep 2026  07:00 AM  →  08:30 AM</a:t>
+                        <a:t>Thu 15 Oct 2026  07:00 AM  →  08:30 AM</a:t>
                       </a:r>
                     </a:p>
                   </a:txBody>
@@ -18763,7 +18763,7 @@
                             <a:srgbClr val="E2E8F0"/>
                           </a:solidFill>
                         </a:rPr>
-                        <a:t>Fri 18 Sep 2026  02:00 AM</a:t>
+                        <a:t>Fri 16 Oct 2026  03:00 AM</a:t>
                       </a:r>
                     </a:p>
                   </a:txBody>
@@ -18805,7 +18805,7 @@
                             <a:srgbClr val="E2E8F0"/>
                           </a:solidFill>
                         </a:rPr>
-                        <a:t>Fri 18 Sep 2026  12:00 AM</a:t>
+                        <a:t>Fri 16 Oct 2026  01:00 AM</a:t>
                       </a:r>
                     </a:p>
                   </a:txBody>
@@ -18847,7 +18847,7 @@
                             <a:srgbClr val="E2E8F0"/>
                           </a:solidFill>
                         </a:rPr>
-                        <a:t>Thu 17 Sep 2026  10:00 PM</a:t>
+                        <a:t>Thu 15 Oct 2026  10:00 PM</a:t>
                       </a:r>
                     </a:p>
                   </a:txBody>
@@ -18889,7 +18889,7 @@
                             <a:srgbClr val="E2E8F0"/>
                           </a:solidFill>
                         </a:rPr>
-                        <a:t>https://events.sumologic.com/mobotessentialsam09172026-event-training</a:t>
+                        <a:t>https://events.sumologic.com/mobotworkshopam10152026-event-training</a:t>
                       </a:r>
                     </a:p>
                   </a:txBody>
@@ -18933,7 +18933,7 @@
                             <a:srgbClr val="E2E8F0"/>
                           </a:solidFill>
                         </a:rPr>
-                        <a:t>Mobot Essentials PM</a:t>
+                        <a:t>Hands on with Mobot and Dojo AI PM</a:t>
                       </a:r>
                     </a:p>
                   </a:txBody>
@@ -18975,7 +18975,7 @@
                             <a:srgbClr val="E2E8F0"/>
                           </a:solidFill>
                         </a:rPr>
-                        <a:t>Thu 17 Sep 2026  01:00 PM  →  05:25 PM</a:t>
+                        <a:t>Thu 15 Oct 2026  04:00 PM  →  05:30 PM</a:t>
                       </a:r>
                     </a:p>
                   </a:txBody>
@@ -19017,7 +19017,7 @@
                             <a:srgbClr val="E2E8F0"/>
                           </a:solidFill>
                         </a:rPr>
-                        <a:t>Fri 18 Sep 2026  08:00 AM</a:t>
+                        <a:t>Fri 16 Oct 2026  12:00 PM</a:t>
                       </a:r>
                     </a:p>
                   </a:txBody>
@@ -19059,7 +19059,7 @@
                             <a:srgbClr val="E2E8F0"/>
                           </a:solidFill>
                         </a:rPr>
-                        <a:t>Fri 18 Sep 2026  06:00 AM</a:t>
+                        <a:t>Fri 16 Oct 2026  10:00 AM</a:t>
                       </a:r>
                     </a:p>
                   </a:txBody>
@@ -19101,7 +19101,7 @@
                             <a:srgbClr val="E2E8F0"/>
                           </a:solidFill>
                         </a:rPr>
-                        <a:t>Fri 18 Sep 2026  04:00 AM</a:t>
+                        <a:t>Fri 16 Oct 2026  07:00 AM</a:t>
                       </a:r>
                     </a:p>
                   </a:txBody>
@@ -19143,7 +19143,7 @@
                             <a:srgbClr val="E2E8F0"/>
                           </a:solidFill>
                         </a:rPr>
-                        <a:t>https://events.sumologic.com/mobotessentialspm09172026-event-training</a:t>
+                        <a:t>https://events.sumologic.com/mobotworkshoppm10152026-event-training</a:t>
                       </a:r>
                     </a:p>
                   </a:txBody>
@@ -19187,7 +19187,7 @@
                             <a:srgbClr val="E2E8F0"/>
                           </a:solidFill>
                         </a:rPr>
-                        <a:t>Essential Cloud SIEM Skills for SOC Analysts AM</a:t>
+                        <a:t>Essential SIEM Skills for SOC Analysts AM</a:t>
                       </a:r>
                     </a:p>
                   </a:txBody>
@@ -19229,7 +19229,7 @@
                             <a:srgbClr val="E2E8F0"/>
                           </a:solidFill>
                         </a:rPr>
-                        <a:t>Tue 22 Sep 2026  07:00 AM  →  08:30 AM</a:t>
+                        <a:t>Tue 20 Oct 2026  07:00 AM  →  08:30 AM</a:t>
                       </a:r>
                     </a:p>
                   </a:txBody>
@@ -19271,7 +19271,7 @@
                             <a:srgbClr val="E2E8F0"/>
                           </a:solidFill>
                         </a:rPr>
-                        <a:t>Wed 23 Sep 2026  02:00 AM</a:t>
+                        <a:t>Wed 21 Oct 2026  03:00 AM</a:t>
                       </a:r>
                     </a:p>
                   </a:txBody>
@@ -19313,7 +19313,7 @@
                             <a:srgbClr val="E2E8F0"/>
                           </a:solidFill>
                         </a:rPr>
-                        <a:t>Wed 23 Sep 2026  12:00 AM</a:t>
+                        <a:t>Wed 21 Oct 2026  01:00 AM</a:t>
                       </a:r>
                     </a:p>
                   </a:txBody>
@@ -19355,7 +19355,7 @@
                             <a:srgbClr val="E2E8F0"/>
                           </a:solidFill>
                         </a:rPr>
-                        <a:t>Tue 22 Sep 2026  10:00 PM</a:t>
+                        <a:t>Tue 20 Oct 2026  10:00 PM</a:t>
                       </a:r>
                     </a:p>
                   </a:txBody>
@@ -19397,7 +19397,7 @@
                             <a:srgbClr val="E2E8F0"/>
                           </a:solidFill>
                         </a:rPr>
-                        <a:t>https://events.sumologic.com/esssiemam09222026-event-training</a:t>
+                        <a:t>https://events.sumologic.com/esssiemam10202026-event-training</a:t>
                       </a:r>
                     </a:p>
                   </a:txBody>
@@ -19441,7 +19441,7 @@
                             <a:srgbClr val="E2E8F0"/>
                           </a:solidFill>
                         </a:rPr>
-                        <a:t>Essential Cloud SIEM Skills for SOC Analysts PM</a:t>
+                        <a:t>Essential SIEM Skills for SOC Analysts PM</a:t>
                       </a:r>
                     </a:p>
                   </a:txBody>
@@ -19483,7 +19483,7 @@
                             <a:srgbClr val="E2E8F0"/>
                           </a:solidFill>
                         </a:rPr>
-                        <a:t>Tue 22 Sep 2026  04:00 PM  →  05:30 PM</a:t>
+                        <a:t>Tue 20 Oct 2026  04:00 PM  →  05:30 PM</a:t>
                       </a:r>
                     </a:p>
                   </a:txBody>
@@ -19525,7 +19525,7 @@
                             <a:srgbClr val="E2E8F0"/>
                           </a:solidFill>
                         </a:rPr>
-                        <a:t>Wed 23 Sep 2026  11:00 AM</a:t>
+                        <a:t>Wed 21 Oct 2026  12:00 PM</a:t>
                       </a:r>
                     </a:p>
                   </a:txBody>
@@ -19567,7 +19567,7 @@
                             <a:srgbClr val="E2E8F0"/>
                           </a:solidFill>
                         </a:rPr>
-                        <a:t>Wed 23 Sep 2026  09:00 AM</a:t>
+                        <a:t>Wed 21 Oct 2026  10:00 AM</a:t>
                       </a:r>
                     </a:p>
                   </a:txBody>
@@ -19609,7 +19609,7 @@
                             <a:srgbClr val="E2E8F0"/>
                           </a:solidFill>
                         </a:rPr>
-                        <a:t>Wed 23 Sep 2026  07:00 AM</a:t>
+                        <a:t>Wed 21 Oct 2026  07:00 AM</a:t>
                       </a:r>
                     </a:p>
                   </a:txBody>
@@ -19651,7 +19651,7 @@
                             <a:srgbClr val="E2E8F0"/>
                           </a:solidFill>
                         </a:rPr>
-                        <a:t>https://events.sumologic.com/esssiempm09222026-event-training</a:t>
+                        <a:t>https://events.sumologic.com/esssiempm10202026-event-training</a:t>
                       </a:r>
                     </a:p>
                   </a:txBody>
@@ -19737,7 +19737,7 @@
                             <a:srgbClr val="E2E8F0"/>
                           </a:solidFill>
                         </a:rPr>
-                        <a:t>Wed 23 Sep 2026  07:00 AM  →  10:00 AM</a:t>
+                        <a:t>Wed 21 Oct 2026  07:00 AM  →  10:00 AM</a:t>
                       </a:r>
                     </a:p>
                   </a:txBody>
@@ -19779,7 +19779,7 @@
                             <a:srgbClr val="E2E8F0"/>
                           </a:solidFill>
                         </a:rPr>
-                        <a:t>Thu 24 Sep 2026  02:00 AM</a:t>
+                        <a:t>Thu 22 Oct 2026  03:00 AM</a:t>
                       </a:r>
                     </a:p>
                   </a:txBody>
@@ -19821,7 +19821,7 @@
                             <a:srgbClr val="E2E8F0"/>
                           </a:solidFill>
                         </a:rPr>
-                        <a:t>Thu 24 Sep 2026  12:00 AM</a:t>
+                        <a:t>Thu 22 Oct 2026  01:00 AM</a:t>
                       </a:r>
                     </a:p>
                   </a:txBody>
@@ -19863,7 +19863,7 @@
                             <a:srgbClr val="E2E8F0"/>
                           </a:solidFill>
                         </a:rPr>
-                        <a:t>Wed 23 Sep 2026  10:00 PM</a:t>
+                        <a:t>Wed 21 Oct 2026  10:00 PM</a:t>
                       </a:r>
                     </a:p>
                   </a:txBody>
@@ -19905,7 +19905,7 @@
                             <a:srgbClr val="E2E8F0"/>
                           </a:solidFill>
                         </a:rPr>
-                        <a:t>https://events.sumologic.com/cloudsiemam09232026-event-training</a:t>
+                        <a:t/>
                       </a:r>
                     </a:p>
                   </a:txBody>
@@ -19949,7 +19949,7 @@
                             <a:srgbClr val="E2E8F0"/>
                           </a:solidFill>
                         </a:rPr>
-                        <a:t>Cloud SIEM PM</a:t>
+                        <a:t>Automation AM</a:t>
                       </a:r>
                     </a:p>
                   </a:txBody>
@@ -19991,7 +19991,7 @@
                             <a:srgbClr val="E2E8F0"/>
                           </a:solidFill>
                         </a:rPr>
-                        <a:t>Wed 23 Sep 2026  04:00 PM  →  07:00 PM</a:t>
+                        <a:t>Thu 22 Oct 2026  07:00 AM  →  08:30 AM</a:t>
                       </a:r>
                     </a:p>
                   </a:txBody>
@@ -20033,7 +20033,7 @@
                             <a:srgbClr val="E2E8F0"/>
                           </a:solidFill>
                         </a:rPr>
-                        <a:t>Thu 24 Sep 2026  11:00 AM</a:t>
+                        <a:t>Fri 23 Oct 2026  03:00 AM</a:t>
                       </a:r>
                     </a:p>
                   </a:txBody>
@@ -20075,7 +20075,7 @@
                             <a:srgbClr val="E2E8F0"/>
                           </a:solidFill>
                         </a:rPr>
-                        <a:t>Thu 24 Sep 2026  09:00 AM</a:t>
+                        <a:t>Fri 23 Oct 2026  01:00 AM</a:t>
                       </a:r>
                     </a:p>
                   </a:txBody>
@@ -20117,7 +20117,7 @@
                             <a:srgbClr val="E2E8F0"/>
                           </a:solidFill>
                         </a:rPr>
-                        <a:t>Thu 24 Sep 2026  07:00 AM</a:t>
+                        <a:t>Thu 22 Oct 2026  10:00 PM</a:t>
                       </a:r>
                     </a:p>
                   </a:txBody>
@@ -20159,7 +20159,7 @@
                             <a:srgbClr val="E2E8F0"/>
                           </a:solidFill>
                         </a:rPr>
-                        <a:t>https://events.sumologic.com/cloudsiempm09232026-event-training</a:t>
+                        <a:t>https://events.sumologic.com/automationam10222026-event-training</a:t>
                       </a:r>
                     </a:p>
                   </a:txBody>
@@ -20203,7 +20203,7 @@
                             <a:srgbClr val="E2E8F0"/>
                           </a:solidFill>
                         </a:rPr>
-                        <a:t>Automation AM</a:t>
+                        <a:t>Automation PM</a:t>
                       </a:r>
                     </a:p>
                   </a:txBody>
@@ -20245,7 +20245,7 @@
                             <a:srgbClr val="E2E8F0"/>
                           </a:solidFill>
                         </a:rPr>
-                        <a:t>Thu 24 Sep 2026  07:00 AM  →  08:30 AM</a:t>
+                        <a:t>Thu 22 Oct 2026  04:00 PM  →  05:30 PM</a:t>
                       </a:r>
                     </a:p>
                   </a:txBody>
@@ -20287,7 +20287,7 @@
                             <a:srgbClr val="E2E8F0"/>
                           </a:solidFill>
                         </a:rPr>
-                        <a:t>Fri 25 Sep 2026  02:00 AM</a:t>
+                        <a:t>Fri 23 Oct 2026  12:00 PM</a:t>
                       </a:r>
                     </a:p>
                   </a:txBody>
@@ -20329,7 +20329,7 @@
                             <a:srgbClr val="E2E8F0"/>
                           </a:solidFill>
                         </a:rPr>
-                        <a:t>Fri 25 Sep 2026  12:00 AM</a:t>
+                        <a:t>Fri 23 Oct 2026  10:00 AM</a:t>
                       </a:r>
                     </a:p>
                   </a:txBody>
@@ -20371,7 +20371,7 @@
                             <a:srgbClr val="E2E8F0"/>
                           </a:solidFill>
                         </a:rPr>
-                        <a:t>Thu 24 Sep 2026  10:00 PM</a:t>
+                        <a:t>Fri 23 Oct 2026  07:00 AM</a:t>
                       </a:r>
                     </a:p>
                   </a:txBody>
@@ -20413,267 +20413,13 @@
                             <a:srgbClr val="E2E8F0"/>
                           </a:solidFill>
                         </a:rPr>
-                        <a:t>https://events.sumologic.com/automationam09242026-event-training</a:t>
+                        <a:t>https://events.sumologic.com/automationpm10222026-event-training</a:t>
                       </a:r>
                     </a:p>
                   </a:txBody>
                   <a:tcPr>
                     <a:solidFill>
                       <a:srgbClr val="0F1117"/>
-                    </a:solidFill>
-                    <a:lnL w="6350" cap="flat">
-                      <a:solidFill>
-                        <a:srgbClr val="2E3348"/>
-                      </a:solidFill>
-                    </a:lnL>
-                    <a:lnR w="6350" cap="flat">
-                      <a:solidFill>
-                        <a:srgbClr val="2E3348"/>
-                      </a:solidFill>
-                    </a:lnR>
-                    <a:lnT w="6350" cap="flat">
-                      <a:solidFill>
-                        <a:srgbClr val="2E3348"/>
-                      </a:solidFill>
-                    </a:lnT>
-                    <a:lnB w="6350" cap="flat">
-                      <a:solidFill>
-                        <a:srgbClr val="2E3348"/>
-                      </a:solidFill>
-                    </a:lnB>
-                  </a:tcPr>
-                </a:tc>
-              </a:tr>
-              <a:tr h="420624">
-                <a:tc>
-                  <a:txBody>
-                    <a:bodyPr wrap="square"/>
-                    <a:lstStyle/>
-                    <a:p>
-                      <a:pPr algn="l"/>
-                      <a:r>
-                        <a:rPr sz="800" b="0">
-                          <a:solidFill>
-                            <a:srgbClr val="E2E8F0"/>
-                          </a:solidFill>
-                        </a:rPr>
-                        <a:t>Automation PM</a:t>
-                      </a:r>
-                    </a:p>
-                  </a:txBody>
-                  <a:tcPr>
-                    <a:solidFill>
-                      <a:srgbClr val="1A1D27"/>
-                    </a:solidFill>
-                    <a:lnL w="6350" cap="flat">
-                      <a:solidFill>
-                        <a:srgbClr val="2E3348"/>
-                      </a:solidFill>
-                    </a:lnL>
-                    <a:lnR w="6350" cap="flat">
-                      <a:solidFill>
-                        <a:srgbClr val="2E3348"/>
-                      </a:solidFill>
-                    </a:lnR>
-                    <a:lnT w="6350" cap="flat">
-                      <a:solidFill>
-                        <a:srgbClr val="2E3348"/>
-                      </a:solidFill>
-                    </a:lnT>
-                    <a:lnB w="6350" cap="flat">
-                      <a:solidFill>
-                        <a:srgbClr val="2E3348"/>
-                      </a:solidFill>
-                    </a:lnB>
-                  </a:tcPr>
-                </a:tc>
-                <a:tc>
-                  <a:txBody>
-                    <a:bodyPr wrap="none"/>
-                    <a:lstStyle/>
-                    <a:p>
-                      <a:pPr algn="l"/>
-                      <a:r>
-                        <a:rPr sz="800" b="0">
-                          <a:solidFill>
-                            <a:srgbClr val="E2E8F0"/>
-                          </a:solidFill>
-                        </a:rPr>
-                        <a:t>Thu 24 Sep 2026  04:00 PM  →  05:30 PM</a:t>
-                      </a:r>
-                    </a:p>
-                  </a:txBody>
-                  <a:tcPr>
-                    <a:solidFill>
-                      <a:srgbClr val="1A1D27"/>
-                    </a:solidFill>
-                    <a:lnL w="6350" cap="flat">
-                      <a:solidFill>
-                        <a:srgbClr val="2E3348"/>
-                      </a:solidFill>
-                    </a:lnL>
-                    <a:lnR w="6350" cap="flat">
-                      <a:solidFill>
-                        <a:srgbClr val="2E3348"/>
-                      </a:solidFill>
-                    </a:lnR>
-                    <a:lnT w="6350" cap="flat">
-                      <a:solidFill>
-                        <a:srgbClr val="2E3348"/>
-                      </a:solidFill>
-                    </a:lnT>
-                    <a:lnB w="6350" cap="flat">
-                      <a:solidFill>
-                        <a:srgbClr val="2E3348"/>
-                      </a:solidFill>
-                    </a:lnB>
-                  </a:tcPr>
-                </a:tc>
-                <a:tc>
-                  <a:txBody>
-                    <a:bodyPr wrap="none"/>
-                    <a:lstStyle/>
-                    <a:p>
-                      <a:pPr algn="l"/>
-                      <a:r>
-                        <a:rPr sz="800" b="0">
-                          <a:solidFill>
-                            <a:srgbClr val="E2E8F0"/>
-                          </a:solidFill>
-                        </a:rPr>
-                        <a:t>Fri 25 Sep 2026  11:00 AM</a:t>
-                      </a:r>
-                    </a:p>
-                  </a:txBody>
-                  <a:tcPr>
-                    <a:solidFill>
-                      <a:srgbClr val="1A1D27"/>
-                    </a:solidFill>
-                    <a:lnL w="6350" cap="flat">
-                      <a:solidFill>
-                        <a:srgbClr val="2E3348"/>
-                      </a:solidFill>
-                    </a:lnL>
-                    <a:lnR w="6350" cap="flat">
-                      <a:solidFill>
-                        <a:srgbClr val="2E3348"/>
-                      </a:solidFill>
-                    </a:lnR>
-                    <a:lnT w="6350" cap="flat">
-                      <a:solidFill>
-                        <a:srgbClr val="2E3348"/>
-                      </a:solidFill>
-                    </a:lnT>
-                    <a:lnB w="6350" cap="flat">
-                      <a:solidFill>
-                        <a:srgbClr val="2E3348"/>
-                      </a:solidFill>
-                    </a:lnB>
-                  </a:tcPr>
-                </a:tc>
-                <a:tc>
-                  <a:txBody>
-                    <a:bodyPr wrap="none"/>
-                    <a:lstStyle/>
-                    <a:p>
-                      <a:pPr algn="l"/>
-                      <a:r>
-                        <a:rPr sz="800" b="0">
-                          <a:solidFill>
-                            <a:srgbClr val="E2E8F0"/>
-                          </a:solidFill>
-                        </a:rPr>
-                        <a:t>Fri 25 Sep 2026  09:00 AM</a:t>
-                      </a:r>
-                    </a:p>
-                  </a:txBody>
-                  <a:tcPr>
-                    <a:solidFill>
-                      <a:srgbClr val="1A1D27"/>
-                    </a:solidFill>
-                    <a:lnL w="6350" cap="flat">
-                      <a:solidFill>
-                        <a:srgbClr val="2E3348"/>
-                      </a:solidFill>
-                    </a:lnL>
-                    <a:lnR w="6350" cap="flat">
-                      <a:solidFill>
-                        <a:srgbClr val="2E3348"/>
-                      </a:solidFill>
-                    </a:lnR>
-                    <a:lnT w="6350" cap="flat">
-                      <a:solidFill>
-                        <a:srgbClr val="2E3348"/>
-                      </a:solidFill>
-                    </a:lnT>
-                    <a:lnB w="6350" cap="flat">
-                      <a:solidFill>
-                        <a:srgbClr val="2E3348"/>
-                      </a:solidFill>
-                    </a:lnB>
-                  </a:tcPr>
-                </a:tc>
-                <a:tc>
-                  <a:txBody>
-                    <a:bodyPr wrap="none"/>
-                    <a:lstStyle/>
-                    <a:p>
-                      <a:pPr algn="l"/>
-                      <a:r>
-                        <a:rPr sz="800" b="0">
-                          <a:solidFill>
-                            <a:srgbClr val="E2E8F0"/>
-                          </a:solidFill>
-                        </a:rPr>
-                        <a:t>Fri 25 Sep 2026  07:00 AM</a:t>
-                      </a:r>
-                    </a:p>
-                  </a:txBody>
-                  <a:tcPr>
-                    <a:solidFill>
-                      <a:srgbClr val="1A1D27"/>
-                    </a:solidFill>
-                    <a:lnL w="6350" cap="flat">
-                      <a:solidFill>
-                        <a:srgbClr val="2E3348"/>
-                      </a:solidFill>
-                    </a:lnL>
-                    <a:lnR w="6350" cap="flat">
-                      <a:solidFill>
-                        <a:srgbClr val="2E3348"/>
-                      </a:solidFill>
-                    </a:lnR>
-                    <a:lnT w="6350" cap="flat">
-                      <a:solidFill>
-                        <a:srgbClr val="2E3348"/>
-                      </a:solidFill>
-                    </a:lnT>
-                    <a:lnB w="6350" cap="flat">
-                      <a:solidFill>
-                        <a:srgbClr val="2E3348"/>
-                      </a:solidFill>
-                    </a:lnB>
-                  </a:tcPr>
-                </a:tc>
-                <a:tc>
-                  <a:txBody>
-                    <a:bodyPr wrap="square"/>
-                    <a:lstStyle/>
-                    <a:p>
-                      <a:pPr algn="l"/>
-                      <a:r>
-                        <a:rPr sz="700" b="0">
-                          <a:solidFill>
-                            <a:srgbClr val="E2E8F0"/>
-                          </a:solidFill>
-                        </a:rPr>
-                        <a:t>https://events.sumologic.com/automationpm09242026-event-training</a:t>
-                      </a:r>
-                    </a:p>
-                  </a:txBody>
-                  <a:tcPr>
-                    <a:solidFill>
-                      <a:srgbClr val="1A1D27"/>
                     </a:solidFill>
                     <a:lnL w="6350" cap="flat">
                       <a:solidFill>
@@ -20710,7 +20456,7 @@
         </p:nvSpPr>
         <p:spPr>
           <a:xfrm>
-            <a:off x="164592" y="4425696"/>
+            <a:off x="164592" y="4005072"/>
             <a:ext cx="11795760" cy="274320"/>
           </a:xfrm>
           <a:prstGeom prst="rect">

</xml_diff>